<commit_message>
Add optional ESBMC-on-Python Box B track to Session 2 labs
Introduce an optional 'Box B' track that runs the same evening trick on
Python input: stage3_esbmc.py re-runs Lab 1 Stage 3 as a program ESBMC
verifies (and shows the 32- vs 64-bit int-width difference), and
safe_div.py is a Lab 2 division-by-zero bonus that fixes to SUCCESSFUL.
Adds a Box B slide to the hands-on and solutions decks, README notes, and
records both verdicts (verified on ESBMC 8.3.0). The Z3 puzzles and the C
ESBMC labs are unchanged.
</commit_message>
<xml_diff>
--- a/instructor/session2-solutions.pptx
+++ b/instructor/session2-solutions.pptx
@@ -17,6 +17,7 @@
     <p:sldId id="265" r:id="rId16"/>
     <p:sldId id="266" r:id="rId17"/>
     <p:sldId id="267" r:id="rId18"/>
+    <p:sldId id="268" r:id="rId19"/>
   </p:sldIdLst>
   <p:sldSz cx="12191695" cy="6858000" type="screen4x3"/>
   <p:notesSz cx="6858000" cy="9144000"/>
@@ -3231,2340 +3232,6 @@
                   <a:srgbClr val="5A0A7A"/>
                 </a:solidFill>
               </a:rPr>
-              <a:t>Lab 4, Track A — race.c</a:t>
-            </a:r>
-          </a:p>
-        </p:txBody>
-      </p:sp>
-      <p:sp>
-        <p:nvSpPr>
-          <p:cNvPr id="3" name="TextBox 2"/>
-          <p:cNvSpPr txBox="1"/>
-          <p:nvPr/>
-        </p:nvSpPr>
-        <p:spPr>
-          <a:xfrm>
-            <a:off x="731520" y="1463040"/>
-            <a:ext cx="10789920" cy="5120640"/>
-          </a:xfrm>
-          <a:prstGeom prst="rect">
-            <a:avLst/>
-          </a:prstGeom>
-          <a:noFill/>
-        </p:spPr>
-        <p:txBody>
-          <a:bodyPr wrap="square">
-            <a:spAutoFit/>
-          </a:bodyPr>
-          <a:lstStyle/>
-          <a:p>
-            <a:pPr>
-              <a:spcAft>
-                <a:spcPts val="800"/>
-              </a:spcAft>
-            </a:pPr>
-            <a:r>
-              <a:rPr sz="2200">
-                <a:solidFill>
-                  <a:srgbClr val="212121"/>
-                </a:solidFill>
-              </a:rPr>
-              <a:t>The failing interleaving, straight from the trace:</a:t>
-            </a:r>
-          </a:p>
-          <a:p>
-            <a:pPr lvl="1">
-              <a:spcAft>
-                <a:spcPts val="0"/>
-              </a:spcAft>
-            </a:pPr>
-            <a:r>
-              <a:rPr sz="1800">
-                <a:solidFill>
-                  <a:srgbClr val="212121"/>
-                </a:solidFill>
-                <a:latin typeface="Courier New"/>
-              </a:rPr>
-              <a:t>State 71 ... function t1 thread 1      g = 1</a:t>
-            </a:r>
-          </a:p>
-          <a:p>
-            <a:pPr lvl="1">
-              <a:spcAft>
-                <a:spcPts val="0"/>
-              </a:spcAft>
-            </a:pPr>
-            <a:r>
-              <a:rPr sz="1800">
-                <a:solidFill>
-                  <a:srgbClr val="212121"/>
-                </a:solidFill>
-                <a:latin typeface="Courier New"/>
-              </a:rPr>
-              <a:t>State 78 ... function t2 thread 2      g = 2</a:t>
-            </a:r>
-          </a:p>
-          <a:p>
-            <a:pPr lvl="1">
-              <a:spcAft>
-                <a:spcPts val="0"/>
-              </a:spcAft>
-            </a:pPr>
-            <a:r>
-              <a:rPr sz="1800">
-                <a:solidFill>
-                  <a:srgbClr val="212121"/>
-                </a:solidFill>
-                <a:latin typeface="Courier New"/>
-              </a:rPr>
-              <a:t>State 87 ... function t1 thread 1</a:t>
-            </a:r>
-          </a:p>
-          <a:p>
-            <a:pPr lvl="1">
-              <a:spcAft>
-                <a:spcPts val="0"/>
-              </a:spcAft>
-            </a:pPr>
-            <a:r>
-              <a:rPr sz="1800">
-                <a:solidFill>
-                  <a:srgbClr val="212121"/>
-                </a:solidFill>
-                <a:latin typeface="Courier New"/>
-              </a:rPr>
-              <a:t>Violated property: assertion t1   (g == 1)</a:t>
-            </a:r>
-          </a:p>
-          <a:p>
-            <a:pPr>
-              <a:spcAft>
-                <a:spcPts val="800"/>
-              </a:spcAft>
-            </a:pPr>
-            <a:r>
-              <a:rPr sz="2200">
-                <a:solidFill>
-                  <a:srgbClr val="212121"/>
-                </a:solidFill>
-              </a:rPr>
-              <a:t/>
-            </a:r>
-          </a:p>
-          <a:p>
-            <a:pPr>
-              <a:spcAft>
-                <a:spcPts val="800"/>
-              </a:spcAft>
-            </a:pPr>
-            <a:r>
-              <a:rPr sz="2200">
-                <a:solidFill>
-                  <a:srgbClr val="212121"/>
-                </a:solidFill>
-              </a:rPr>
-              <a:t>Fix (race_fixed.c): one mutex makes write-then-check atomic — lock around g = 1; assert(g == 1); in t1 and around g = 2 in t2.</a:t>
-            </a:r>
-          </a:p>
-          <a:p>
-            <a:pPr lvl="1">
-              <a:spcAft>
-                <a:spcPts val="0"/>
-              </a:spcAft>
-            </a:pPr>
-            <a:r>
-              <a:rPr sz="1800">
-                <a:solidFill>
-                  <a:srgbClr val="212121"/>
-                </a:solidFill>
-                <a:latin typeface="Courier New"/>
-              </a:rPr>
-              <a:t>esbmc race_fixed.c --context-bound 2  =&gt;  SUCCESSFUL</a:t>
-            </a:r>
-          </a:p>
-        </p:txBody>
-      </p:sp>
-    </p:spTree>
-  </p:cSld>
-  <p:clrMapOvr>
-    <a:masterClrMapping/>
-  </p:clrMapOvr>
-</p:sld>
-</file>
-
-<file path=ppt/slides/slide11.xml><?xml version="1.0" encoding="utf-8"?>
-<p:sld xmlns:a="http://schemas.openxmlformats.org/drawingml/2006/main" xmlns:p="http://schemas.openxmlformats.org/presentationml/2006/main" xmlns:r="http://schemas.openxmlformats.org/officeDocument/2006/relationships">
-  <p:cSld>
-    <p:spTree>
-      <p:nvGrpSpPr>
-        <p:cNvPr id="1" name=""/>
-        <p:cNvGrpSpPr/>
-        <p:nvPr/>
-      </p:nvGrpSpPr>
-      <p:grpSpPr/>
-      <p:sp>
-        <p:nvSpPr>
-          <p:cNvPr id="2" name="TextBox 1"/>
-          <p:cNvSpPr txBox="1"/>
-          <p:nvPr/>
-        </p:nvSpPr>
-        <p:spPr>
-          <a:xfrm>
-            <a:off x="548640" y="365760"/>
-            <a:ext cx="11064240" cy="1005840"/>
-          </a:xfrm>
-          <a:prstGeom prst="rect">
-            <a:avLst/>
-          </a:prstGeom>
-          <a:noFill/>
-        </p:spPr>
-        <p:txBody>
-          <a:bodyPr wrap="square">
-            <a:spAutoFit/>
-          </a:bodyPr>
-          <a:lstStyle/>
-          <a:p>
-            <a:r>
-              <a:rPr sz="3600" b="1">
-                <a:solidFill>
-                  <a:srgbClr val="5A0A7A"/>
-                </a:solidFill>
-              </a:rPr>
-              <a:t>Lab 4, Track B — float.c</a:t>
-            </a:r>
-          </a:p>
-        </p:txBody>
-      </p:sp>
-      <p:sp>
-        <p:nvSpPr>
-          <p:cNvPr id="3" name="TextBox 2"/>
-          <p:cNvSpPr txBox="1"/>
-          <p:nvPr/>
-        </p:nvSpPr>
-        <p:spPr>
-          <a:xfrm>
-            <a:off x="731520" y="1463040"/>
-            <a:ext cx="10789920" cy="5120640"/>
-          </a:xfrm>
-          <a:prstGeom prst="rect">
-            <a:avLst/>
-          </a:prstGeom>
-          <a:noFill/>
-        </p:spPr>
-        <p:txBody>
-          <a:bodyPr wrap="square">
-            <a:spAutoFit/>
-          </a:bodyPr>
-          <a:lstStyle/>
-          <a:p>
-            <a:pPr>
-              <a:spcAft>
-                <a:spcPts val="800"/>
-              </a:spcAft>
-            </a:pPr>
-            <a:r>
-              <a:rPr sz="2200">
-                <a:solidFill>
-                  <a:srgbClr val="212121"/>
-                </a:solidFill>
-              </a:rPr>
-              <a:t>FAILED is the correct verdict — the program is genuinely wrong.</a:t>
-            </a:r>
-          </a:p>
-          <a:p>
-            <a:pPr lvl="1">
-              <a:spcAft>
-                <a:spcPts val="800"/>
-              </a:spcAft>
-            </a:pPr>
-            <a:r>
-              <a:rPr sz="2000">
-                <a:solidFill>
-                  <a:srgbClr val="212121"/>
-                </a:solidFill>
-              </a:rPr>
-              <a:t>0.1, 0.2 and 0.3 have no exact binary64 representation — same reason 1/3 has none in decimal.</a:t>
-            </a:r>
-          </a:p>
-          <a:p>
-            <a:pPr lvl="1">
-              <a:spcAft>
-                <a:spcPts val="800"/>
-              </a:spcAft>
-            </a:pPr>
-            <a:r>
-              <a:rPr sz="2000">
-                <a:solidFill>
-                  <a:srgbClr val="212121"/>
-                </a:solidFill>
-              </a:rPr>
-              <a:t>0.1 + 0.2 rounds to the double nearest 0.30000000000000004, which is not the double nearest 0.3.</a:t>
-            </a:r>
-          </a:p>
-          <a:p>
-            <a:pPr>
-              <a:spcAft>
-                <a:spcPts val="800"/>
-              </a:spcAft>
-            </a:pPr>
-            <a:r>
-              <a:rPr sz="2200">
-                <a:solidFill>
-                  <a:srgbClr val="212121"/>
-                </a:solidFill>
-              </a:rPr>
-              <a:t/>
-            </a:r>
-          </a:p>
-          <a:p>
-            <a:pPr>
-              <a:spcAft>
-                <a:spcPts val="800"/>
-              </a:spcAft>
-            </a:pPr>
-            <a:r>
-              <a:rPr sz="2200">
-                <a:solidFill>
-                  <a:srgbClr val="212121"/>
-                </a:solidFill>
-              </a:rPr>
-              <a:t>There is no float_fixed.c — by design. Discuss the remedies:</a:t>
-            </a:r>
-          </a:p>
-          <a:p>
-            <a:pPr lvl="1">
-              <a:spcAft>
-                <a:spcPts val="0"/>
-              </a:spcAft>
-            </a:pPr>
-            <a:r>
-              <a:rPr sz="1800">
-                <a:solidFill>
-                  <a:srgbClr val="212121"/>
-                </a:solidFill>
-                <a:latin typeface="Courier New"/>
-              </a:rPr>
-              <a:t>compare with an epsilon: fabs(w - z) &lt; 1e-9</a:t>
-            </a:r>
-          </a:p>
-          <a:p>
-            <a:pPr lvl="1">
-              <a:spcAft>
-                <a:spcPts val="800"/>
-              </a:spcAft>
-            </a:pPr>
-            <a:r>
-              <a:rPr sz="2000">
-                <a:solidFill>
-                  <a:srgbClr val="212121"/>
-                </a:solidFill>
-              </a:rPr>
-              <a:t>use decimal / fixed-point where exactness matters (money!)</a:t>
-            </a:r>
-          </a:p>
-          <a:p>
-            <a:pPr lvl="1">
-              <a:spcAft>
-                <a:spcPts val="800"/>
-              </a:spcAft>
-            </a:pPr>
-            <a:r>
-              <a:rPr sz="2000">
-                <a:solidFill>
-                  <a:srgbClr val="212121"/>
-                </a:solidFill>
-              </a:rPr>
-              <a:t>or specify the property you actually mean.</a:t>
-            </a:r>
-          </a:p>
-        </p:txBody>
-      </p:sp>
-    </p:spTree>
-  </p:cSld>
-  <p:clrMapOvr>
-    <a:masterClrMapping/>
-  </p:clrMapOvr>
-</p:sld>
-</file>
-
-<file path=ppt/slides/slide12.xml><?xml version="1.0" encoding="utf-8"?>
-<p:sld xmlns:a="http://schemas.openxmlformats.org/drawingml/2006/main" xmlns:p="http://schemas.openxmlformats.org/presentationml/2006/main" xmlns:r="http://schemas.openxmlformats.org/officeDocument/2006/relationships">
-  <p:cSld>
-    <p:spTree>
-      <p:nvGrpSpPr>
-        <p:cNvPr id="1" name=""/>
-        <p:cNvGrpSpPr/>
-        <p:nvPr/>
-      </p:nvGrpSpPr>
-      <p:grpSpPr/>
-      <p:sp>
-        <p:nvSpPr>
-          <p:cNvPr id="2" name="TextBox 1"/>
-          <p:cNvSpPr txBox="1"/>
-          <p:nvPr/>
-        </p:nvSpPr>
-        <p:spPr>
-          <a:xfrm>
-            <a:off x="548640" y="365760"/>
-            <a:ext cx="11064240" cy="1005840"/>
-          </a:xfrm>
-          <a:prstGeom prst="rect">
-            <a:avLst/>
-          </a:prstGeom>
-          <a:noFill/>
-        </p:spPr>
-        <p:txBody>
-          <a:bodyPr wrap="square">
-            <a:spAutoFit/>
-          </a:bodyPr>
-          <a:lstStyle/>
-          <a:p>
-            <a:r>
-              <a:rPr sz="3600" b="1">
-                <a:solidFill>
-                  <a:srgbClr val="5A0A7A"/>
-                </a:solidFill>
-              </a:rPr>
-              <a:t>Master verdict table (fallback if live demos die)</a:t>
-            </a:r>
-          </a:p>
-        </p:txBody>
-      </p:sp>
-      <p:graphicFrame>
-        <p:nvGraphicFramePr>
-          <p:cNvPr id="3" name="Table 2"/>
-          <p:cNvGraphicFramePr>
-            <a:graphicFrameLocks noGrp="1"/>
-          </p:cNvGraphicFramePr>
-          <p:nvPr/>
-        </p:nvGraphicFramePr>
-        <p:xfrm>
-          <a:off x="731520" y="1463040"/>
-          <a:ext cx="10698480" cy="3291840"/>
-        </p:xfrm>
-        <a:graphic>
-          <a:graphicData uri="http://schemas.openxmlformats.org/drawingml/2006/table">
-            <a:tbl>
-              <a:tblPr firstRow="1" bandRow="1">
-                <a:tableStyleId>{5C22544A-7EE6-4342-B048-85BDC9FD1C3A}</a:tableStyleId>
-              </a:tblPr>
-              <a:tblGrid>
-                <a:gridCol w="1737360"/>
-                <a:gridCol w="4206240"/>
-                <a:gridCol w="2651760"/>
-                <a:gridCol w="2103120"/>
-              </a:tblGrid>
-              <a:tr h="365760">
-                <a:tc>
-                  <a:txBody>
-                    <a:bodyPr/>
-                    <a:lstStyle/>
-                    <a:p>
-                      <a:r>
-                        <a:rPr sz="1300" b="1"/>
-                        <a:t>File</a:t>
-                      </a:r>
-                    </a:p>
-                  </a:txBody>
-                  <a:tcPr/>
-                </a:tc>
-                <a:tc>
-                  <a:txBody>
-                    <a:bodyPr/>
-                    <a:lstStyle/>
-                    <a:p>
-                      <a:r>
-                        <a:rPr sz="1300" b="1"/>
-                        <a:t>Command</a:t>
-                      </a:r>
-                    </a:p>
-                  </a:txBody>
-                  <a:tcPr/>
-                </a:tc>
-                <a:tc>
-                  <a:txBody>
-                    <a:bodyPr/>
-                    <a:lstStyle/>
-                    <a:p>
-                      <a:r>
-                        <a:rPr sz="1300" b="1"/>
-                        <a:t>Buggy</a:t>
-                      </a:r>
-                    </a:p>
-                  </a:txBody>
-                  <a:tcPr/>
-                </a:tc>
-                <a:tc>
-                  <a:txBody>
-                    <a:bodyPr/>
-                    <a:lstStyle/>
-                    <a:p>
-                      <a:r>
-                        <a:rPr sz="1300" b="1"/>
-                        <a:t>Fixed</a:t>
-                      </a:r>
-                    </a:p>
-                  </a:txBody>
-                  <a:tcPr/>
-                </a:tc>
-              </a:tr>
-              <a:tr h="365760">
-                <a:tc>
-                  <a:txBody>
-                    <a:bodyPr/>
-                    <a:lstStyle/>
-                    <a:p>
-                      <a:r>
-                        <a:rPr sz="1300"/>
-                        <a:t>overflow.c</a:t>
-                      </a:r>
-                    </a:p>
-                  </a:txBody>
-                  <a:tcPr/>
-                </a:tc>
-                <a:tc>
-                  <a:txBody>
-                    <a:bodyPr/>
-                    <a:lstStyle/>
-                    <a:p>
-                      <a:r>
-                        <a:rPr sz="1300"/>
-                        <a:t>esbmc overflow.c</a:t>
-                      </a:r>
-                    </a:p>
-                  </a:txBody>
-                  <a:tcPr/>
-                </a:tc>
-                <a:tc>
-                  <a:txBody>
-                    <a:bodyPr/>
-                    <a:lstStyle/>
-                    <a:p>
-                      <a:r>
-                        <a:rPr sz="1300"/>
-                        <a:t>FAILED</a:t>
-                      </a:r>
-                    </a:p>
-                  </a:txBody>
-                  <a:tcPr/>
-                </a:tc>
-                <a:tc>
-                  <a:txBody>
-                    <a:bodyPr/>
-                    <a:lstStyle/>
-                    <a:p>
-                      <a:r>
-                        <a:rPr sz="1300"/>
-                        <a:t>SUCCESSFUL</a:t>
-                      </a:r>
-                    </a:p>
-                  </a:txBody>
-                  <a:tcPr/>
-                </a:tc>
-              </a:tr>
-              <a:tr h="365760">
-                <a:tc>
-                  <a:txBody>
-                    <a:bodyPr/>
-                    <a:lstStyle/>
-                    <a:p>
-                      <a:r>
-                        <a:rPr sz="1300"/>
-                        <a:t>leak.c</a:t>
-                      </a:r>
-                    </a:p>
-                  </a:txBody>
-                  <a:tcPr/>
-                </a:tc>
-                <a:tc>
-                  <a:txBody>
-                    <a:bodyPr/>
-                    <a:lstStyle/>
-                    <a:p>
-                      <a:r>
-                        <a:rPr sz="1300"/>
-                        <a:t>esbmc leak.c --memory-leak-check</a:t>
-                      </a:r>
-                    </a:p>
-                  </a:txBody>
-                  <a:tcPr/>
-                </a:tc>
-                <a:tc>
-                  <a:txBody>
-                    <a:bodyPr/>
-                    <a:lstStyle/>
-                    <a:p>
-                      <a:r>
-                        <a:rPr sz="1300"/>
-                        <a:t>FAILED</a:t>
-                      </a:r>
-                    </a:p>
-                  </a:txBody>
-                  <a:tcPr/>
-                </a:tc>
-                <a:tc>
-                  <a:txBody>
-                    <a:bodyPr/>
-                    <a:lstStyle/>
-                    <a:p>
-                      <a:r>
-                        <a:rPr sz="1300"/>
-                        <a:t>SUCCESSFUL</a:t>
-                      </a:r>
-                    </a:p>
-                  </a:txBody>
-                  <a:tcPr/>
-                </a:tc>
-              </a:tr>
-              <a:tr h="365760">
-                <a:tc>
-                  <a:txBody>
-                    <a:bodyPr/>
-                    <a:lstStyle/>
-                    <a:p>
-                      <a:r>
-                        <a:rPr sz="1300"/>
-                        <a:t>vla.c</a:t>
-                      </a:r>
-                    </a:p>
-                  </a:txBody>
-                  <a:tcPr/>
-                </a:tc>
-                <a:tc>
-                  <a:txBody>
-                    <a:bodyPr/>
-                    <a:lstStyle/>
-                    <a:p>
-                      <a:r>
-                        <a:rPr sz="1300"/>
-                        <a:t>esbmc vla.c --unwind 6</a:t>
-                      </a:r>
-                    </a:p>
-                  </a:txBody>
-                  <a:tcPr/>
-                </a:tc>
-                <a:tc>
-                  <a:txBody>
-                    <a:bodyPr/>
-                    <a:lstStyle/>
-                    <a:p>
-                      <a:r>
-                        <a:rPr sz="1300"/>
-                        <a:t>FAILED</a:t>
-                      </a:r>
-                    </a:p>
-                  </a:txBody>
-                  <a:tcPr/>
-                </a:tc>
-                <a:tc>
-                  <a:txBody>
-                    <a:bodyPr/>
-                    <a:lstStyle/>
-                    <a:p>
-                      <a:r>
-                        <a:rPr sz="1300"/>
-                        <a:t>SUCCESSFUL</a:t>
-                      </a:r>
-                    </a:p>
-                  </a:txBody>
-                  <a:tcPr/>
-                </a:tc>
-              </a:tr>
-              <a:tr h="365760">
-                <a:tc>
-                  <a:txBody>
-                    <a:bodyPr/>
-                    <a:lstStyle/>
-                    <a:p>
-                      <a:r>
-                        <a:rPr sz="1300"/>
-                        <a:t>getpassword.c</a:t>
-                      </a:r>
-                    </a:p>
-                  </a:txBody>
-                  <a:tcPr/>
-                </a:tc>
-                <a:tc>
-                  <a:txBody>
-                    <a:bodyPr/>
-                    <a:lstStyle/>
-                    <a:p>
-                      <a:r>
-                        <a:rPr sz="1300"/>
-                        <a:t>esbmc getpassword.c --unwind 8</a:t>
-                      </a:r>
-                    </a:p>
-                  </a:txBody>
-                  <a:tcPr/>
-                </a:tc>
-                <a:tc>
-                  <a:txBody>
-                    <a:bodyPr/>
-                    <a:lstStyle/>
-                    <a:p>
-                      <a:r>
-                        <a:rPr sz="1300"/>
-                        <a:t>FAILED</a:t>
-                      </a:r>
-                    </a:p>
-                  </a:txBody>
-                  <a:tcPr/>
-                </a:tc>
-                <a:tc>
-                  <a:txBody>
-                    <a:bodyPr/>
-                    <a:lstStyle/>
-                    <a:p>
-                      <a:r>
-                        <a:rPr sz="1300"/>
-                        <a:t>SUCCESSFUL (--unwind 10)</a:t>
-                      </a:r>
-                    </a:p>
-                  </a:txBody>
-                  <a:tcPr/>
-                </a:tc>
-              </a:tr>
-              <a:tr h="365760">
-                <a:tc>
-                  <a:txBody>
-                    <a:bodyPr/>
-                    <a:lstStyle/>
-                    <a:p>
-                      <a:r>
-                        <a:rPr sz="1300"/>
-                        <a:t>triangle.c</a:t>
-                      </a:r>
-                    </a:p>
-                  </a:txBody>
-                  <a:tcPr/>
-                </a:tc>
-                <a:tc>
-                  <a:txBody>
-                    <a:bodyPr/>
-                    <a:lstStyle/>
-                    <a:p>
-                      <a:r>
-                        <a:rPr sz="1300"/>
-                        <a:t>esbmc triangle.c</a:t>
-                      </a:r>
-                    </a:p>
-                  </a:txBody>
-                  <a:tcPr/>
-                </a:tc>
-                <a:tc>
-                  <a:txBody>
-                    <a:bodyPr/>
-                    <a:lstStyle/>
-                    <a:p>
-                      <a:r>
-                        <a:rPr sz="1300"/>
-                        <a:t>SUCCESSFUL (weak spec!)</a:t>
-                      </a:r>
-                    </a:p>
-                  </a:txBody>
-                  <a:tcPr/>
-                </a:tc>
-                <a:tc>
-                  <a:txBody>
-                    <a:bodyPr/>
-                    <a:lstStyle/>
-                    <a:p>
-                      <a:r>
-                        <a:rPr sz="1300"/>
-                        <a:t>SUCCESSFUL (full spec)</a:t>
-                      </a:r>
-                    </a:p>
-                  </a:txBody>
-                  <a:tcPr/>
-                </a:tc>
-              </a:tr>
-              <a:tr h="365760">
-                <a:tc>
-                  <a:txBody>
-                    <a:bodyPr/>
-                    <a:lstStyle/>
-                    <a:p>
-                      <a:r>
-                        <a:rPr sz="1300"/>
-                        <a:t>unwind.c</a:t>
-                      </a:r>
-                    </a:p>
-                  </a:txBody>
-                  <a:tcPr/>
-                </a:tc>
-                <a:tc>
-                  <a:txBody>
-                    <a:bodyPr/>
-                    <a:lstStyle/>
-                    <a:p>
-                      <a:r>
-                        <a:rPr sz="1300"/>
-                        <a:t>--unwind 5 / 20 / 60 / --k-induction</a:t>
-                      </a:r>
-                    </a:p>
-                  </a:txBody>
-                  <a:tcPr/>
-                </a:tc>
-                <a:tc>
-                  <a:txBody>
-                    <a:bodyPr/>
-                    <a:lstStyle/>
-                    <a:p>
-                      <a:r>
-                        <a:rPr sz="1300"/>
-                        <a:t>F / F / S / UNKNOWN</a:t>
-                      </a:r>
-                    </a:p>
-                  </a:txBody>
-                  <a:tcPr/>
-                </a:tc>
-                <a:tc>
-                  <a:txBody>
-                    <a:bodyPr/>
-                    <a:lstStyle/>
-                    <a:p>
-                      <a:r>
-                        <a:rPr sz="1300"/>
-                        <a:t>—</a:t>
-                      </a:r>
-                    </a:p>
-                  </a:txBody>
-                  <a:tcPr/>
-                </a:tc>
-              </a:tr>
-              <a:tr h="365760">
-                <a:tc>
-                  <a:txBody>
-                    <a:bodyPr/>
-                    <a:lstStyle/>
-                    <a:p>
-                      <a:r>
-                        <a:rPr sz="1300"/>
-                        <a:t>race.c</a:t>
-                      </a:r>
-                    </a:p>
-                  </a:txBody>
-                  <a:tcPr/>
-                </a:tc>
-                <a:tc>
-                  <a:txBody>
-                    <a:bodyPr/>
-                    <a:lstStyle/>
-                    <a:p>
-                      <a:r>
-                        <a:rPr sz="1300"/>
-                        <a:t>esbmc race.c --context-bound 2</a:t>
-                      </a:r>
-                    </a:p>
-                  </a:txBody>
-                  <a:tcPr/>
-                </a:tc>
-                <a:tc>
-                  <a:txBody>
-                    <a:bodyPr/>
-                    <a:lstStyle/>
-                    <a:p>
-                      <a:r>
-                        <a:rPr sz="1300"/>
-                        <a:t>FAILED</a:t>
-                      </a:r>
-                    </a:p>
-                  </a:txBody>
-                  <a:tcPr/>
-                </a:tc>
-                <a:tc>
-                  <a:txBody>
-                    <a:bodyPr/>
-                    <a:lstStyle/>
-                    <a:p>
-                      <a:r>
-                        <a:rPr sz="1300"/>
-                        <a:t>SUCCESSFUL</a:t>
-                      </a:r>
-                    </a:p>
-                  </a:txBody>
-                  <a:tcPr/>
-                </a:tc>
-              </a:tr>
-              <a:tr h="365760">
-                <a:tc>
-                  <a:txBody>
-                    <a:bodyPr/>
-                    <a:lstStyle/>
-                    <a:p>
-                      <a:r>
-                        <a:rPr sz="1300"/>
-                        <a:t>float.c</a:t>
-                      </a:r>
-                    </a:p>
-                  </a:txBody>
-                  <a:tcPr/>
-                </a:tc>
-                <a:tc>
-                  <a:txBody>
-                    <a:bodyPr/>
-                    <a:lstStyle/>
-                    <a:p>
-                      <a:r>
-                        <a:rPr sz="1300"/>
-                        <a:t>esbmc float.c</a:t>
-                      </a:r>
-                    </a:p>
-                  </a:txBody>
-                  <a:tcPr/>
-                </a:tc>
-                <a:tc>
-                  <a:txBody>
-                    <a:bodyPr/>
-                    <a:lstStyle/>
-                    <a:p>
-                      <a:r>
-                        <a:rPr sz="1300"/>
-                        <a:t>FAILED</a:t>
-                      </a:r>
-                    </a:p>
-                  </a:txBody>
-                  <a:tcPr/>
-                </a:tc>
-                <a:tc>
-                  <a:txBody>
-                    <a:bodyPr/>
-                    <a:lstStyle/>
-                    <a:p>
-                      <a:r>
-                        <a:rPr sz="1300"/>
-                        <a:t>— (by design)</a:t>
-                      </a:r>
-                    </a:p>
-                  </a:txBody>
-                  <a:tcPr/>
-                </a:tc>
-              </a:tr>
-            </a:tbl>
-          </a:graphicData>
-        </a:graphic>
-      </p:graphicFrame>
-    </p:spTree>
-  </p:cSld>
-  <p:clrMapOvr>
-    <a:masterClrMapping/>
-  </p:clrMapOvr>
-</p:sld>
-</file>
-
-<file path=ppt/slides/slide2.xml><?xml version="1.0" encoding="utf-8"?>
-<p:sld xmlns:a="http://schemas.openxmlformats.org/drawingml/2006/main" xmlns:p="http://schemas.openxmlformats.org/presentationml/2006/main" xmlns:r="http://schemas.openxmlformats.org/officeDocument/2006/relationships">
-  <p:cSld>
-    <p:spTree>
-      <p:nvGrpSpPr>
-        <p:cNvPr id="1" name=""/>
-        <p:cNvGrpSpPr/>
-        <p:nvPr/>
-      </p:nvGrpSpPr>
-      <p:grpSpPr/>
-      <p:sp>
-        <p:nvSpPr>
-          <p:cNvPr id="2" name="TextBox 1"/>
-          <p:cNvSpPr txBox="1"/>
-          <p:nvPr/>
-        </p:nvSpPr>
-        <p:spPr>
-          <a:xfrm>
-            <a:off x="548640" y="365760"/>
-            <a:ext cx="11064240" cy="1005840"/>
-          </a:xfrm>
-          <a:prstGeom prst="rect">
-            <a:avLst/>
-          </a:prstGeom>
-          <a:noFill/>
-        </p:spPr>
-        <p:txBody>
-          <a:bodyPr wrap="square">
-            <a:spAutoFit/>
-          </a:bodyPr>
-          <a:lstStyle/>
-          <a:p>
-            <a:r>
-              <a:rPr sz="3600" b="1">
-                <a:solidFill>
-                  <a:srgbClr val="5A0A7A"/>
-                </a:solidFill>
-              </a:rPr>
-              <a:t>Lab 1, Stage 1 — answers</a:t>
-            </a:r>
-          </a:p>
-        </p:txBody>
-      </p:sp>
-      <p:sp>
-        <p:nvSpPr>
-          <p:cNvPr id="3" name="TextBox 2"/>
-          <p:cNvSpPr txBox="1"/>
-          <p:nvPr/>
-        </p:nvSpPr>
-        <p:spPr>
-          <a:xfrm>
-            <a:off x="731520" y="1463040"/>
-            <a:ext cx="10789920" cy="5120640"/>
-          </a:xfrm>
-          <a:prstGeom prst="rect">
-            <a:avLst/>
-          </a:prstGeom>
-          <a:noFill/>
-        </p:spPr>
-        <p:txBody>
-          <a:bodyPr wrap="square">
-            <a:spAutoFit/>
-          </a:bodyPr>
-          <a:lstStyle/>
-          <a:p>
-            <a:pPr>
-              <a:spcAft>
-                <a:spcPts val="800"/>
-              </a:spcAft>
-            </a:pPr>
-            <a:r>
-              <a:rPr sz="2200">
-                <a:solidFill>
-                  <a:srgbClr val="212121"/>
-                </a:solidFill>
-              </a:rPr>
-              <a:t>1c: NOT equivalent — counterexample [b = False].</a:t>
-            </a:r>
-          </a:p>
-          <a:p>
-            <a:pPr lvl="1">
-              <a:spcAft>
-                <a:spcPts val="800"/>
-              </a:spcAft>
-            </a:pPr>
-            <a:r>
-              <a:rPr sz="2000">
-                <a:solidFill>
-                  <a:srgbClr val="212121"/>
-                </a:solidFill>
-              </a:rPr>
-              <a:t>With b false, a → (b → a) is true but b is false.</a:t>
-            </a:r>
-          </a:p>
-          <a:p>
-            <a:pPr>
-              <a:spcAft>
-                <a:spcPts val="800"/>
-              </a:spcAft>
-            </a:pPr>
-            <a:r>
-              <a:rPr sz="2200">
-                <a:solidFill>
-                  <a:srgbClr val="212121"/>
-                </a:solidFill>
-              </a:rPr>
-              <a:t/>
-            </a:r>
-          </a:p>
-          <a:p>
-            <a:pPr>
-              <a:spcAft>
-                <a:spcPts val="800"/>
-              </a:spcAft>
-            </a:pPr>
-            <a:r>
-              <a:rPr sz="2200">
-                <a:solidFill>
-                  <a:srgbClr val="212121"/>
-                </a:solidFill>
-              </a:rPr>
-              <a:t>1d (the TODO): implication is NOT associative.</a:t>
-            </a:r>
-          </a:p>
-          <a:p>
-            <a:pPr lvl="1">
-              <a:spcAft>
-                <a:spcPts val="0"/>
-              </a:spcAft>
-            </a:pPr>
-            <a:r>
-              <a:rPr sz="1800">
-                <a:solidFill>
-                  <a:srgbClr val="212121"/>
-                </a:solidFill>
-                <a:latin typeface="Courier New"/>
-              </a:rPr>
-              <a:t>equivalent(Implies(Implies(a, b), c),</a:t>
-            </a:r>
-          </a:p>
-          <a:p>
-            <a:pPr lvl="1">
-              <a:spcAft>
-                <a:spcPts val="0"/>
-              </a:spcAft>
-            </a:pPr>
-            <a:r>
-              <a:rPr sz="1800">
-                <a:solidFill>
-                  <a:srgbClr val="212121"/>
-                </a:solidFill>
-                <a:latin typeface="Courier New"/>
-              </a:rPr>
-              <a:t>           Implies(a, Implies(b, c)), "1d")</a:t>
-            </a:r>
-          </a:p>
-          <a:p>
-            <a:pPr lvl="1">
-              <a:spcAft>
-                <a:spcPts val="800"/>
-              </a:spcAft>
-            </a:pPr>
-            <a:r>
-              <a:rPr sz="2000">
-                <a:solidFill>
-                  <a:srgbClr val="212121"/>
-                </a:solidFill>
-              </a:rPr>
-              <a:t>Counterexample: a and c both false — lhs is false (T → F), rhs is true (F → anything).</a:t>
-            </a:r>
-          </a:p>
-        </p:txBody>
-      </p:sp>
-    </p:spTree>
-  </p:cSld>
-  <p:clrMapOvr>
-    <a:masterClrMapping/>
-  </p:clrMapOvr>
-</p:sld>
-</file>
-
-<file path=ppt/slides/slide3.xml><?xml version="1.0" encoding="utf-8"?>
-<p:sld xmlns:a="http://schemas.openxmlformats.org/drawingml/2006/main" xmlns:p="http://schemas.openxmlformats.org/presentationml/2006/main" xmlns:r="http://schemas.openxmlformats.org/officeDocument/2006/relationships">
-  <p:cSld>
-    <p:spTree>
-      <p:nvGrpSpPr>
-        <p:cNvPr id="1" name=""/>
-        <p:cNvGrpSpPr/>
-        <p:nvPr/>
-      </p:nvGrpSpPr>
-      <p:grpSpPr/>
-      <p:sp>
-        <p:nvSpPr>
-          <p:cNvPr id="2" name="TextBox 1"/>
-          <p:cNvSpPr txBox="1"/>
-          <p:nvPr/>
-        </p:nvSpPr>
-        <p:spPr>
-          <a:xfrm>
-            <a:off x="548640" y="365760"/>
-            <a:ext cx="11064240" cy="1005840"/>
-          </a:xfrm>
-          <a:prstGeom prst="rect">
-            <a:avLst/>
-          </a:prstGeom>
-          <a:noFill/>
-        </p:spPr>
-        <p:txBody>
-          <a:bodyPr wrap="square">
-            <a:spAutoFit/>
-          </a:bodyPr>
-          <a:lstStyle/>
-          <a:p>
-            <a:r>
-              <a:rPr sz="3600" b="1">
-                <a:solidFill>
-                  <a:srgbClr val="5A0A7A"/>
-                </a:solidFill>
-              </a:rPr>
-              <a:t>Lab 1, Stages 2–3 — answers</a:t>
-            </a:r>
-          </a:p>
-        </p:txBody>
-      </p:sp>
-      <p:sp>
-        <p:nvSpPr>
-          <p:cNvPr id="3" name="TextBox 2"/>
-          <p:cNvSpPr txBox="1"/>
-          <p:nvPr/>
-        </p:nvSpPr>
-        <p:spPr>
-          <a:xfrm>
-            <a:off x="731520" y="1463040"/>
-            <a:ext cx="10789920" cy="5120640"/>
-          </a:xfrm>
-          <a:prstGeom prst="rect">
-            <a:avLst/>
-          </a:prstGeom>
-          <a:noFill/>
-        </p:spPr>
-        <p:txBody>
-          <a:bodyPr wrap="square">
-            <a:spAutoFit/>
-          </a:bodyPr>
-          <a:lstStyle/>
-          <a:p>
-            <a:pPr>
-              <a:spcAft>
-                <a:spcPts val="800"/>
-              </a:spcAft>
-            </a:pPr>
-            <a:r>
-              <a:rPr sz="2200">
-                <a:solidFill>
-                  <a:srgbClr val="212121"/>
-                </a:solidFill>
-              </a:rPr>
-              <a:t>Stage 2 — the missing constraint:</a:t>
-            </a:r>
-          </a:p>
-          <a:p>
-            <a:pPr lvl="1">
-              <a:spcAft>
-                <a:spcPts val="0"/>
-              </a:spcAft>
-            </a:pPr>
-            <a:r>
-              <a:rPr sz="1800">
-                <a:solidFill>
-                  <a:srgbClr val="212121"/>
-                </a:solidFill>
-                <a:latin typeface="Courier New"/>
-              </a:rPr>
-              <a:t>send  = 1000*S + 100*E + 10*N + D   (more, money alike)</a:t>
-            </a:r>
-          </a:p>
-          <a:p>
-            <a:pPr lvl="1">
-              <a:spcAft>
-                <a:spcPts val="0"/>
-              </a:spcAft>
-            </a:pPr>
-            <a:r>
-              <a:rPr sz="1800">
-                <a:solidFill>
-                  <a:srgbClr val="212121"/>
-                </a:solidFill>
-                <a:latin typeface="Courier New"/>
-              </a:rPr>
-              <a:t>s.add(send + more == money)</a:t>
-            </a:r>
-          </a:p>
-          <a:p>
-            <a:pPr lvl="1">
-              <a:spcAft>
-                <a:spcPts val="800"/>
-              </a:spcAft>
-            </a:pPr>
-            <a:r>
-              <a:rPr sz="2000">
-                <a:solidFill>
-                  <a:srgbClr val="212121"/>
-                </a:solidFill>
-              </a:rPr>
-              <a:t>Unique model: 9567 + 1085 = 10652</a:t>
-            </a:r>
-          </a:p>
-          <a:p>
-            <a:pPr>
-              <a:spcAft>
-                <a:spcPts val="800"/>
-              </a:spcAft>
-            </a:pPr>
-            <a:r>
-              <a:rPr sz="2200">
-                <a:solidFill>
-                  <a:srgbClr val="212121"/>
-                </a:solidFill>
-              </a:rPr>
-              <a:t/>
-            </a:r>
-          </a:p>
-          <a:p>
-            <a:pPr>
-              <a:spcAft>
-                <a:spcPts val="800"/>
-              </a:spcAft>
-            </a:pPr>
-            <a:r>
-              <a:rPr sz="2200">
-                <a:solidFill>
-                  <a:srgbClr val="212121"/>
-                </a:solidFill>
-              </a:rPr>
-              <a:t>Stage 3, Q3 — still sat even with x &gt;= 0:</a:t>
-            </a:r>
-          </a:p>
-          <a:p>
-            <a:pPr lvl="1">
-              <a:spcAft>
-                <a:spcPts val="800"/>
-              </a:spcAft>
-            </a:pPr>
-            <a:r>
-              <a:rPr sz="2000">
-                <a:solidFill>
-                  <a:srgbClr val="212121"/>
-                </a:solidFill>
-              </a:rPr>
-              <a:t>x = 0x7FFFFFFF wraps y to INT_MIN; 2 * INT_MIN wraps to 0 &lt; 2.</a:t>
-            </a:r>
-          </a:p>
-          <a:p>
-            <a:pPr lvl="1">
-              <a:spcAft>
-                <a:spcPts val="800"/>
-              </a:spcAft>
-            </a:pPr>
-            <a:r>
-              <a:rPr sz="2000">
-                <a:solidFill>
-                  <a:srgbClr val="212121"/>
-                </a:solidFill>
-              </a:rPr>
-              <a:t>Same bug class --overflow-check hunts in Lab 2.</a:t>
-            </a:r>
-          </a:p>
-        </p:txBody>
-      </p:sp>
-    </p:spTree>
-  </p:cSld>
-  <p:clrMapOvr>
-    <a:masterClrMapping/>
-  </p:clrMapOvr>
-</p:sld>
-</file>
-
-<file path=ppt/slides/slide4.xml><?xml version="1.0" encoding="utf-8"?>
-<p:sld xmlns:a="http://schemas.openxmlformats.org/drawingml/2006/main" xmlns:p="http://schemas.openxmlformats.org/presentationml/2006/main" xmlns:r="http://schemas.openxmlformats.org/officeDocument/2006/relationships">
-  <p:cSld>
-    <p:spTree>
-      <p:nvGrpSpPr>
-        <p:cNvPr id="1" name=""/>
-        <p:cNvGrpSpPr/>
-        <p:nvPr/>
-      </p:nvGrpSpPr>
-      <p:grpSpPr/>
-      <p:sp>
-        <p:nvSpPr>
-          <p:cNvPr id="2" name="TextBox 1"/>
-          <p:cNvSpPr txBox="1"/>
-          <p:nvPr/>
-        </p:nvSpPr>
-        <p:spPr>
-          <a:xfrm>
-            <a:off x="548640" y="365760"/>
-            <a:ext cx="11064240" cy="1005840"/>
-          </a:xfrm>
-          <a:prstGeom prst="rect">
-            <a:avLst/>
-          </a:prstGeom>
-          <a:noFill/>
-        </p:spPr>
-        <p:txBody>
-          <a:bodyPr wrap="square">
-            <a:spAutoFit/>
-          </a:bodyPr>
-          <a:lstStyle/>
-          <a:p>
-            <a:r>
-              <a:rPr sz="3600" b="1">
-                <a:solidFill>
-                  <a:srgbClr val="5A0A7A"/>
-                </a:solidFill>
-              </a:rPr>
-              <a:t>Lab 2 — overflow.c</a:t>
-            </a:r>
-          </a:p>
-        </p:txBody>
-      </p:sp>
-      <p:sp>
-        <p:nvSpPr>
-          <p:cNvPr id="3" name="TextBox 2"/>
-          <p:cNvSpPr txBox="1"/>
-          <p:nvPr/>
-        </p:nvSpPr>
-        <p:spPr>
-          <a:xfrm>
-            <a:off x="731520" y="1463040"/>
-            <a:ext cx="10789920" cy="5120640"/>
-          </a:xfrm>
-          <a:prstGeom prst="rect">
-            <a:avLst/>
-          </a:prstGeom>
-          <a:noFill/>
-        </p:spPr>
-        <p:txBody>
-          <a:bodyPr wrap="square">
-            <a:spAutoFit/>
-          </a:bodyPr>
-          <a:lstStyle/>
-          <a:p>
-            <a:pPr>
-              <a:spcAft>
-                <a:spcPts val="800"/>
-              </a:spcAft>
-            </a:pPr>
-            <a:r>
-              <a:rPr sz="2200">
-                <a:solidFill>
-                  <a:srgbClr val="212121"/>
-                </a:solidFill>
-              </a:rPr>
-              <a:t>Verdict: FAILED — solver picks i = -1, x = -1; the write lands on a[0], a[1] stays garbage.</a:t>
-            </a:r>
-          </a:p>
-          <a:p>
-            <a:pPr>
-              <a:spcAft>
-                <a:spcPts val="800"/>
-              </a:spcAft>
-            </a:pPr>
-            <a:r>
-              <a:rPr sz="2200">
-                <a:solidFill>
-                  <a:srgbClr val="212121"/>
-                </a:solidFill>
-              </a:rPr>
-              <a:t/>
-            </a:r>
-          </a:p>
-          <a:p>
-            <a:pPr>
-              <a:spcAft>
-                <a:spcPts val="800"/>
-              </a:spcAft>
-            </a:pPr>
-            <a:r>
-              <a:rPr sz="2200">
-                <a:solidFill>
-                  <a:srgbClr val="212121"/>
-                </a:solidFill>
-              </a:rPr>
-              <a:t>Fix (overflow_fixed.c): repair the index AND the spec — keep x untrusted:</a:t>
-            </a:r>
-          </a:p>
-          <a:p>
-            <a:pPr lvl="1">
-              <a:spcAft>
-                <a:spcPts val="0"/>
-              </a:spcAft>
-            </a:pPr>
-            <a:r>
-              <a:rPr sz="1800">
-                <a:solidFill>
-                  <a:srgbClr val="212121"/>
-                </a:solidFill>
-                <a:latin typeface="Courier New"/>
-              </a:rPr>
-              <a:t>int a[2] = {0, 0};  int i = 0;  int x = nondet_int();</a:t>
-            </a:r>
-          </a:p>
-          <a:p>
-            <a:pPr lvl="1">
-              <a:spcAft>
-                <a:spcPts val="0"/>
-              </a:spcAft>
-            </a:pPr>
-            <a:r>
-              <a:rPr sz="1800">
-                <a:solidFill>
-                  <a:srgbClr val="212121"/>
-                </a:solidFill>
-                <a:latin typeface="Courier New"/>
-              </a:rPr>
-              <a:t>assert(x == 0 ? *(p + i) == 0 : *(p + i + 1) == 1);</a:t>
-            </a:r>
-          </a:p>
-          <a:p>
-            <a:pPr lvl="1">
-              <a:spcAft>
-                <a:spcPts val="0"/>
-              </a:spcAft>
-            </a:pPr>
-            <a:r>
-              <a:rPr sz="1800">
-                <a:solidFill>
-                  <a:srgbClr val="212121"/>
-                </a:solidFill>
-                <a:latin typeface="Courier New"/>
-              </a:rPr>
-              <a:t>esbmc overflow_fixed.c  =&gt;  VERIFICATION SUCCESSFUL</a:t>
-            </a:r>
-          </a:p>
-          <a:p>
-            <a:pPr>
-              <a:spcAft>
-                <a:spcPts val="800"/>
-              </a:spcAft>
-            </a:pPr>
-            <a:r>
-              <a:rPr sz="2200">
-                <a:solidFill>
-                  <a:srgbClr val="212121"/>
-                </a:solidFill>
-              </a:rPr>
-              <a:t/>
-            </a:r>
-          </a:p>
-          <a:p>
-            <a:pPr>
-              <a:spcAft>
-                <a:spcPts val="800"/>
-              </a:spcAft>
-            </a:pPr>
-            <a:r>
-              <a:rPr sz="2200">
-                <a:solidFill>
-                  <a:srgbClr val="212121"/>
-                </a:solidFill>
-              </a:rPr>
-              <a:t>Takeaway: fix the index and the assertion; the input stays nondet.</a:t>
-            </a:r>
-          </a:p>
-        </p:txBody>
-      </p:sp>
-    </p:spTree>
-  </p:cSld>
-  <p:clrMapOvr>
-    <a:masterClrMapping/>
-  </p:clrMapOvr>
-</p:sld>
-</file>
-
-<file path=ppt/slides/slide5.xml><?xml version="1.0" encoding="utf-8"?>
-<p:sld xmlns:a="http://schemas.openxmlformats.org/drawingml/2006/main" xmlns:p="http://schemas.openxmlformats.org/presentationml/2006/main" xmlns:r="http://schemas.openxmlformats.org/officeDocument/2006/relationships">
-  <p:cSld>
-    <p:spTree>
-      <p:nvGrpSpPr>
-        <p:cNvPr id="1" name=""/>
-        <p:cNvGrpSpPr/>
-        <p:nvPr/>
-      </p:nvGrpSpPr>
-      <p:grpSpPr/>
-      <p:sp>
-        <p:nvSpPr>
-          <p:cNvPr id="2" name="TextBox 1"/>
-          <p:cNvSpPr txBox="1"/>
-          <p:nvPr/>
-        </p:nvSpPr>
-        <p:spPr>
-          <a:xfrm>
-            <a:off x="548640" y="365760"/>
-            <a:ext cx="11064240" cy="1005840"/>
-          </a:xfrm>
-          <a:prstGeom prst="rect">
-            <a:avLst/>
-          </a:prstGeom>
-          <a:noFill/>
-        </p:spPr>
-        <p:txBody>
-          <a:bodyPr wrap="square">
-            <a:spAutoFit/>
-          </a:bodyPr>
-          <a:lstStyle/>
-          <a:p>
-            <a:r>
-              <a:rPr sz="3600" b="1">
-                <a:solidFill>
-                  <a:srgbClr val="5A0A7A"/>
-                </a:solidFill>
-              </a:rPr>
-              <a:t>Lab 2 — leak.c</a:t>
-            </a:r>
-          </a:p>
-        </p:txBody>
-      </p:sp>
-      <p:sp>
-        <p:nvSpPr>
-          <p:cNvPr id="3" name="TextBox 2"/>
-          <p:cNvSpPr txBox="1"/>
-          <p:nvPr/>
-        </p:nvSpPr>
-        <p:spPr>
-          <a:xfrm>
-            <a:off x="731520" y="1463040"/>
-            <a:ext cx="10789920" cy="5120640"/>
-          </a:xfrm>
-          <a:prstGeom prst="rect">
-            <a:avLst/>
-          </a:prstGeom>
-          <a:noFill/>
-        </p:spPr>
-        <p:txBody>
-          <a:bodyPr wrap="square">
-            <a:spAutoFit/>
-          </a:bodyPr>
-          <a:lstStyle/>
-          <a:p>
-            <a:pPr>
-              <a:spcAft>
-                <a:spcPts val="0"/>
-              </a:spcAft>
-            </a:pPr>
-            <a:r>
-              <a:rPr sz="1800">
-                <a:solidFill>
-                  <a:srgbClr val="212121"/>
-                </a:solidFill>
-                <a:latin typeface="Courier New"/>
-              </a:rPr>
-              <a:t>dereference failure: forgotten memory: dynamic_1_array</a:t>
-            </a:r>
-          </a:p>
-          <a:p>
-            <a:pPr>
-              <a:spcAft>
-                <a:spcPts val="0"/>
-              </a:spcAft>
-            </a:pPr>
-            <a:r>
-              <a:rPr sz="1800">
-                <a:solidFill>
-                  <a:srgbClr val="212121"/>
-                </a:solidFill>
-                <a:latin typeface="Courier New"/>
-              </a:rPr>
-              <a:t>CWE: CWE-401</a:t>
-            </a:r>
-          </a:p>
-          <a:p>
-            <a:pPr>
-              <a:spcAft>
-                <a:spcPts val="800"/>
-              </a:spcAft>
-            </a:pPr>
-            <a:r>
-              <a:rPr sz="2200">
-                <a:solidFill>
-                  <a:srgbClr val="212121"/>
-                </a:solidFill>
-              </a:rPr>
-              <a:t/>
-            </a:r>
-          </a:p>
-          <a:p>
-            <a:pPr>
-              <a:spcAft>
-                <a:spcPts val="800"/>
-              </a:spcAft>
-            </a:pPr>
-            <a:r>
-              <a:rPr sz="2200">
-                <a:solidFill>
-                  <a:srgbClr val="212121"/>
-                </a:solidFill>
-              </a:rPr>
-              <a:t>p = q overwrote the only pointer to the first malloc(5) — those 5 bytes can never be freed.</a:t>
-            </a:r>
-          </a:p>
-          <a:p>
-            <a:pPr>
-              <a:spcAft>
-                <a:spcPts val="800"/>
-              </a:spcAft>
-            </a:pPr>
-            <a:r>
-              <a:rPr sz="2200">
-                <a:solidFill>
-                  <a:srgbClr val="212121"/>
-                </a:solidFill>
-              </a:rPr>
-              <a:t/>
-            </a:r>
-          </a:p>
-          <a:p>
-            <a:pPr>
-              <a:spcAft>
-                <a:spcPts val="800"/>
-              </a:spcAft>
-            </a:pPr>
-            <a:r>
-              <a:rPr sz="2200">
-                <a:solidFill>
-                  <a:srgbClr val="212121"/>
-                </a:solidFill>
-              </a:rPr>
-              <a:t>Fix (leak_fixed.c): free(p) BEFORE aliasing it.</a:t>
-            </a:r>
-          </a:p>
-          <a:p>
-            <a:pPr lvl="1">
-              <a:spcAft>
-                <a:spcPts val="0"/>
-              </a:spcAft>
-            </a:pPr>
-            <a:r>
-              <a:rPr sz="1800">
-                <a:solidFill>
-                  <a:srgbClr val="212121"/>
-                </a:solidFill>
-                <a:latin typeface="Courier New"/>
-              </a:rPr>
-              <a:t>esbmc leak_fixed.c --memory-leak-check  =&gt;  SUCCESSFUL</a:t>
-            </a:r>
-          </a:p>
-          <a:p>
-            <a:pPr>
-              <a:spcAft>
-                <a:spcPts val="800"/>
-              </a:spcAft>
-            </a:pPr>
-            <a:r>
-              <a:rPr sz="2200">
-                <a:solidFill>
-                  <a:srgbClr val="212121"/>
-                </a:solidFill>
-              </a:rPr>
-              <a:t/>
-            </a:r>
-          </a:p>
-          <a:p>
-            <a:pPr>
-              <a:spcAft>
-                <a:spcPts val="800"/>
-              </a:spcAft>
-            </a:pPr>
-            <a:r>
-              <a:rPr sz="2200">
-                <a:solidFill>
-                  <a:srgbClr val="212121"/>
-                </a:solidFill>
-              </a:rPr>
-              <a:t>Takeaway: a leak is unreachable memory, not just un-freed memory.</a:t>
-            </a:r>
-          </a:p>
-        </p:txBody>
-      </p:sp>
-    </p:spTree>
-  </p:cSld>
-  <p:clrMapOvr>
-    <a:masterClrMapping/>
-  </p:clrMapOvr>
-</p:sld>
-</file>
-
-<file path=ppt/slides/slide6.xml><?xml version="1.0" encoding="utf-8"?>
-<p:sld xmlns:a="http://schemas.openxmlformats.org/drawingml/2006/main" xmlns:p="http://schemas.openxmlformats.org/presentationml/2006/main" xmlns:r="http://schemas.openxmlformats.org/officeDocument/2006/relationships">
-  <p:cSld>
-    <p:spTree>
-      <p:nvGrpSpPr>
-        <p:cNvPr id="1" name=""/>
-        <p:cNvGrpSpPr/>
-        <p:nvPr/>
-      </p:nvGrpSpPr>
-      <p:grpSpPr/>
-      <p:sp>
-        <p:nvSpPr>
-          <p:cNvPr id="2" name="TextBox 1"/>
-          <p:cNvSpPr txBox="1"/>
-          <p:nvPr/>
-        </p:nvSpPr>
-        <p:spPr>
-          <a:xfrm>
-            <a:off x="548640" y="365760"/>
-            <a:ext cx="11064240" cy="1005840"/>
-          </a:xfrm>
-          <a:prstGeom prst="rect">
-            <a:avLst/>
-          </a:prstGeom>
-          <a:noFill/>
-        </p:spPr>
-        <p:txBody>
-          <a:bodyPr wrap="square">
-            <a:spAutoFit/>
-          </a:bodyPr>
-          <a:lstStyle/>
-          <a:p>
-            <a:r>
-              <a:rPr sz="3600" b="1">
-                <a:solidFill>
-                  <a:srgbClr val="5A0A7A"/>
-                </a:solidFill>
-              </a:rPr>
-              <a:t>Lab 2 — vla.c (two bugs)</a:t>
-            </a:r>
-          </a:p>
-        </p:txBody>
-      </p:sp>
-      <p:sp>
-        <p:nvSpPr>
-          <p:cNvPr id="3" name="TextBox 2"/>
-          <p:cNvSpPr txBox="1"/>
-          <p:nvPr/>
-        </p:nvSpPr>
-        <p:spPr>
-          <a:xfrm>
-            <a:off x="731520" y="1463040"/>
-            <a:ext cx="10789920" cy="5120640"/>
-          </a:xfrm>
-          <a:prstGeom prst="rect">
-            <a:avLst/>
-          </a:prstGeom>
-          <a:noFill/>
-        </p:spPr>
-        <p:txBody>
-          <a:bodyPr wrap="square">
-            <a:spAutoFit/>
-          </a:bodyPr>
-          <a:lstStyle/>
-          <a:p>
-            <a:pPr>
-              <a:spcAft>
-                <a:spcPts val="800"/>
-              </a:spcAft>
-            </a:pPr>
-            <a:r>
-              <a:rPr sz="2200">
-                <a:solidFill>
-                  <a:srgbClr val="212121"/>
-                </a:solidFill>
-              </a:rPr>
-              <a:t>Bug 1: the loop runs to size + 1 — one write past a VLA of size n when size == n.</a:t>
-            </a:r>
-          </a:p>
-          <a:p>
-            <a:pPr>
-              <a:spcAft>
-                <a:spcPts val="800"/>
-              </a:spcAft>
-            </a:pPr>
-            <a:r>
-              <a:rPr sz="2200">
-                <a:solidFill>
-                  <a:srgbClr val="212121"/>
-                </a:solidFill>
-              </a:rPr>
-              <a:t>Bug 2: the first call is foo(0, b, 0) — a zero-sized VLA is undefined behaviour before any access.</a:t>
-            </a:r>
-          </a:p>
-          <a:p>
-            <a:pPr>
-              <a:spcAft>
-                <a:spcPts val="800"/>
-              </a:spcAft>
-            </a:pPr>
-            <a:r>
-              <a:rPr sz="2200">
-                <a:solidFill>
-                  <a:srgbClr val="212121"/>
-                </a:solidFill>
-              </a:rPr>
-              <a:t/>
-            </a:r>
-          </a:p>
-          <a:p>
-            <a:pPr>
-              <a:spcAft>
-                <a:spcPts val="800"/>
-              </a:spcAft>
-            </a:pPr>
-            <a:r>
-              <a:rPr sz="2200">
-                <a:solidFill>
-                  <a:srgbClr val="212121"/>
-                </a:solidFill>
-              </a:rPr>
-              <a:t>Fix (vla_fixed.c): guard the sizes, loop strictly below size:</a:t>
-            </a:r>
-          </a:p>
-          <a:p>
-            <a:pPr lvl="1">
-              <a:spcAft>
-                <a:spcPts val="0"/>
-              </a:spcAft>
-            </a:pPr>
-            <a:r>
-              <a:rPr sz="1800">
-                <a:solidFill>
-                  <a:srgbClr val="212121"/>
-                </a:solidFill>
-                <a:latin typeface="Courier New"/>
-              </a:rPr>
-              <a:t>if (n &lt;= 0 || size &gt; n) return 0;</a:t>
-            </a:r>
-          </a:p>
-          <a:p>
-            <a:pPr lvl="1">
-              <a:spcAft>
-                <a:spcPts val="0"/>
-              </a:spcAft>
-            </a:pPr>
-            <a:r>
-              <a:rPr sz="1800">
-                <a:solidFill>
-                  <a:srgbClr val="212121"/>
-                </a:solidFill>
-                <a:latin typeface="Courier New"/>
-              </a:rPr>
-              <a:t>for (i = 0; i &lt; size; i++) a[i] = b[i];</a:t>
-            </a:r>
-          </a:p>
-          <a:p>
-            <a:pPr lvl="1">
-              <a:spcAft>
-                <a:spcPts val="0"/>
-              </a:spcAft>
-            </a:pPr>
-            <a:r>
-              <a:rPr sz="1800">
-                <a:solidFill>
-                  <a:srgbClr val="212121"/>
-                </a:solidFill>
-                <a:latin typeface="Courier New"/>
-              </a:rPr>
-              <a:t>esbmc vla_fixed.c --unwind 6  =&gt;  VERIFICATION SUCCESSFUL</a:t>
-            </a:r>
-          </a:p>
-        </p:txBody>
-      </p:sp>
-    </p:spTree>
-  </p:cSld>
-  <p:clrMapOvr>
-    <a:masterClrMapping/>
-  </p:clrMapOvr>
-</p:sld>
-</file>
-
-<file path=ppt/slides/slide7.xml><?xml version="1.0" encoding="utf-8"?>
-<p:sld xmlns:a="http://schemas.openxmlformats.org/drawingml/2006/main" xmlns:p="http://schemas.openxmlformats.org/presentationml/2006/main" xmlns:r="http://schemas.openxmlformats.org/officeDocument/2006/relationships">
-  <p:cSld>
-    <p:spTree>
-      <p:nvGrpSpPr>
-        <p:cNvPr id="1" name=""/>
-        <p:cNvGrpSpPr/>
-        <p:nvPr/>
-      </p:nvGrpSpPr>
-      <p:grpSpPr/>
-      <p:sp>
-        <p:nvSpPr>
-          <p:cNvPr id="2" name="TextBox 1"/>
-          <p:cNvSpPr txBox="1"/>
-          <p:nvPr/>
-        </p:nvSpPr>
-        <p:spPr>
-          <a:xfrm>
-            <a:off x="548640" y="365760"/>
-            <a:ext cx="11064240" cy="1005840"/>
-          </a:xfrm>
-          <a:prstGeom prst="rect">
-            <a:avLst/>
-          </a:prstGeom>
-          <a:noFill/>
-        </p:spPr>
-        <p:txBody>
-          <a:bodyPr wrap="square">
-            <a:spAutoFit/>
-          </a:bodyPr>
-          <a:lstStyle/>
-          <a:p>
-            <a:r>
-              <a:rPr sz="3600" b="1">
-                <a:solidFill>
-                  <a:srgbClr val="5A0A7A"/>
-                </a:solidFill>
-              </a:rPr>
-              <a:t>Lab 2 — getpassword.c (stretch)</a:t>
-            </a:r>
-          </a:p>
-        </p:txBody>
-      </p:sp>
-      <p:sp>
-        <p:nvSpPr>
-          <p:cNvPr id="3" name="TextBox 2"/>
-          <p:cNvSpPr txBox="1"/>
-          <p:nvPr/>
-        </p:nvSpPr>
-        <p:spPr>
-          <a:xfrm>
-            <a:off x="731520" y="1463040"/>
-            <a:ext cx="10789920" cy="5120640"/>
-          </a:xfrm>
-          <a:prstGeom prst="rect">
-            <a:avLst/>
-          </a:prstGeom>
-          <a:noFill/>
-        </p:spPr>
-        <p:txBody>
-          <a:bodyPr wrap="square">
-            <a:spAutoFit/>
-          </a:bodyPr>
-          <a:lstStyle/>
-          <a:p>
-            <a:pPr>
-              <a:spcAft>
-                <a:spcPts val="800"/>
-              </a:spcAft>
-            </a:pPr>
-            <a:r>
-              <a:rPr sz="2200">
-                <a:solidFill>
-                  <a:srgbClr val="212121"/>
-                </a:solidFill>
-              </a:rPr>
-              <a:t>Fix (getpassword_fixed.c): bounded read, strip the newline:</a:t>
-            </a:r>
-          </a:p>
-          <a:p>
-            <a:pPr lvl="1">
-              <a:spcAft>
-                <a:spcPts val="0"/>
-              </a:spcAft>
-            </a:pPr>
-            <a:r>
-              <a:rPr sz="1800">
-                <a:solidFill>
-                  <a:srgbClr val="212121"/>
-                </a:solidFill>
-                <a:latin typeface="Courier New"/>
-              </a:rPr>
-              <a:t>if (!fgets(buf, sizeof(buf), stdin)) return 1;</a:t>
-            </a:r>
-          </a:p>
-          <a:p>
-            <a:pPr lvl="1">
-              <a:spcAft>
-                <a:spcPts val="0"/>
-              </a:spcAft>
-            </a:pPr>
-            <a:r>
-              <a:rPr sz="1800">
-                <a:solidFill>
-                  <a:srgbClr val="212121"/>
-                </a:solidFill>
-                <a:latin typeface="Courier New"/>
-              </a:rPr>
-              <a:t>buf[strcspn(buf, "\n")] = '\0';</a:t>
-            </a:r>
-          </a:p>
-          <a:p>
-            <a:pPr>
-              <a:spcAft>
-                <a:spcPts val="800"/>
-              </a:spcAft>
-            </a:pPr>
-            <a:r>
-              <a:rPr sz="2200">
-                <a:solidFill>
-                  <a:srgbClr val="212121"/>
-                </a:solidFill>
-              </a:rPr>
-              <a:t/>
-            </a:r>
-          </a:p>
-          <a:p>
-            <a:pPr>
-              <a:spcAft>
-                <a:spcPts val="800"/>
-              </a:spcAft>
-            </a:pPr>
-            <a:r>
-              <a:rPr sz="2200">
-                <a:solidFill>
-                  <a:srgbClr val="212121"/>
-                </a:solidFill>
-              </a:rPr>
-              <a:t>Gotcha: the fixed file (char buf[8]) needs --unwind 10, not 8 — the fgets model iterates further.</a:t>
-            </a:r>
-          </a:p>
-          <a:p>
-            <a:pPr lvl="1">
-              <a:spcAft>
-                <a:spcPts val="800"/>
-              </a:spcAft>
-            </a:pPr>
-            <a:r>
-              <a:rPr sz="2000">
-                <a:solidFill>
-                  <a:srgbClr val="212121"/>
-                </a:solidFill>
-              </a:rPr>
-              <a:t>A minimal fix keeping buf[4] verifies at --unwind 8.</a:t>
-            </a:r>
-          </a:p>
-          <a:p>
-            <a:pPr>
-              <a:spcAft>
-                <a:spcPts val="800"/>
-              </a:spcAft>
-            </a:pPr>
-            <a:r>
-              <a:rPr sz="2200">
-                <a:solidFill>
-                  <a:srgbClr val="212121"/>
-                </a:solidFill>
-              </a:rPr>
-              <a:t/>
-            </a:r>
-          </a:p>
-          <a:p>
-            <a:pPr>
-              <a:spcAft>
-                <a:spcPts val="800"/>
-              </a:spcAft>
-            </a:pPr>
-            <a:r>
-              <a:rPr sz="2200">
-                <a:solidFill>
-                  <a:srgbClr val="212121"/>
-                </a:solidFill>
-              </a:rPr>
-              <a:t>Discussion bridge: why does the right bound depend on the code? → Lab 3, Part 2.</a:t>
-            </a:r>
-          </a:p>
-        </p:txBody>
-      </p:sp>
-    </p:spTree>
-  </p:cSld>
-  <p:clrMapOvr>
-    <a:masterClrMapping/>
-  </p:clrMapOvr>
-</p:sld>
-</file>
-
-<file path=ppt/slides/slide8.xml><?xml version="1.0" encoding="utf-8"?>
-<p:sld xmlns:a="http://schemas.openxmlformats.org/drawingml/2006/main" xmlns:p="http://schemas.openxmlformats.org/presentationml/2006/main" xmlns:r="http://schemas.openxmlformats.org/officeDocument/2006/relationships">
-  <p:cSld>
-    <p:spTree>
-      <p:nvGrpSpPr>
-        <p:cNvPr id="1" name=""/>
-        <p:cNvGrpSpPr/>
-        <p:nvPr/>
-      </p:nvGrpSpPr>
-      <p:grpSpPr/>
-      <p:sp>
-        <p:nvSpPr>
-          <p:cNvPr id="2" name="TextBox 1"/>
-          <p:cNvSpPr txBox="1"/>
-          <p:nvPr/>
-        </p:nvSpPr>
-        <p:spPr>
-          <a:xfrm>
-            <a:off x="548640" y="365760"/>
-            <a:ext cx="11064240" cy="1005840"/>
-          </a:xfrm>
-          <a:prstGeom prst="rect">
-            <a:avLst/>
-          </a:prstGeom>
-          <a:noFill/>
-        </p:spPr>
-        <p:txBody>
-          <a:bodyPr wrap="square">
-            <a:spAutoFit/>
-          </a:bodyPr>
-          <a:lstStyle/>
-          <a:p>
-            <a:r>
-              <a:rPr sz="3600" b="1">
-                <a:solidFill>
-                  <a:srgbClr val="5A0A7A"/>
-                </a:solidFill>
-              </a:rPr>
-              <a:t>Lab 3 — triangle.c</a:t>
-            </a:r>
-          </a:p>
-        </p:txBody>
-      </p:sp>
-      <p:sp>
-        <p:nvSpPr>
-          <p:cNvPr id="3" name="TextBox 2"/>
-          <p:cNvSpPr txBox="1"/>
-          <p:nvPr/>
-        </p:nvSpPr>
-        <p:spPr>
-          <a:xfrm>
-            <a:off x="731520" y="1463040"/>
-            <a:ext cx="10789920" cy="5120640"/>
-          </a:xfrm>
-          <a:prstGeom prst="rect">
-            <a:avLst/>
-          </a:prstGeom>
-          <a:noFill/>
-        </p:spPr>
-        <p:txBody>
-          <a:bodyPr wrap="square">
-            <a:spAutoFit/>
-          </a:bodyPr>
-          <a:lstStyle/>
-          <a:p>
-            <a:pPr>
-              <a:spcAft>
-                <a:spcPts val="800"/>
-              </a:spcAft>
-            </a:pPr>
-            <a:r>
-              <a:rPr sz="2200">
-                <a:solidFill>
-                  <a:srgbClr val="212121"/>
-                </a:solidFill>
-              </a:rPr>
-              <a:t>Seeded bug: classify() forgot the third inequality b + c &lt;= a.</a:t>
-            </a:r>
-          </a:p>
-          <a:p>
-            <a:pPr>
-              <a:spcAft>
-                <a:spcPts val="800"/>
-              </a:spcAft>
-            </a:pPr>
-            <a:r>
-              <a:rPr sz="2200">
-                <a:solidFill>
-                  <a:srgbClr val="212121"/>
-                </a:solidFill>
-              </a:rPr>
-              <a:t/>
-            </a:r>
-          </a:p>
-          <a:p>
-            <a:pPr>
-              <a:spcAft>
-                <a:spcPts val="800"/>
-              </a:spcAft>
-            </a:pPr>
-            <a:r>
-              <a:rPr sz="2200">
-                <a:solidFill>
-                  <a:srgbClr val="212121"/>
-                </a:solidFill>
-              </a:rPr>
-              <a:t>The two TODO properties (triangle_solution.c):</a:t>
-            </a:r>
-          </a:p>
-          <a:p>
-            <a:pPr lvl="1">
-              <a:spcAft>
-                <a:spcPts val="0"/>
-              </a:spcAft>
-            </a:pPr>
-            <a:r>
-              <a:rPr sz="1800">
-                <a:solidFill>
-                  <a:srgbClr val="212121"/>
-                </a:solidFill>
-                <a:latin typeface="Courier New"/>
-              </a:rPr>
-              <a:t>assert(!(a+b&lt;=c || a+c&lt;=b || b+c&lt;=a) || r == 4);  /* P3 */</a:t>
-            </a:r>
-          </a:p>
-          <a:p>
-            <a:pPr lvl="1">
-              <a:spcAft>
-                <a:spcPts val="0"/>
-              </a:spcAft>
-            </a:pPr>
-            <a:r>
-              <a:rPr sz="1800">
-                <a:solidFill>
-                  <a:srgbClr val="212121"/>
-                </a:solidFill>
-                <a:latin typeface="Courier New"/>
-              </a:rPr>
-              <a:t>assert(classify(a, b, c) == classify(c, b, a));   /* P4 */</a:t>
-            </a:r>
-          </a:p>
-          <a:p>
-            <a:pPr>
-              <a:spcAft>
-                <a:spcPts val="800"/>
-              </a:spcAft>
-            </a:pPr>
-            <a:r>
-              <a:rPr sz="2200">
-                <a:solidFill>
-                  <a:srgbClr val="212121"/>
-                </a:solidFill>
-              </a:rPr>
-              <a:t/>
-            </a:r>
-          </a:p>
-          <a:p>
-            <a:pPr>
-              <a:spcAft>
-                <a:spcPts val="800"/>
-              </a:spcAft>
-            </a:pPr>
-            <a:r>
-              <a:rPr sz="2200">
-                <a:solidFill>
-                  <a:srgbClr val="212121"/>
-                </a:solidFill>
-              </a:rPr>
-              <a:t>Observed counterexamples — both correct outcomes of the same bug:</a:t>
-            </a:r>
-          </a:p>
-          <a:p>
-            <a:pPr lvl="1">
-              <a:spcAft>
-                <a:spcPts val="800"/>
-              </a:spcAft>
-            </a:pPr>
-            <a:r>
-              <a:rPr sz="2000">
-                <a:solidFill>
-                  <a:srgbClr val="212121"/>
-                </a:solidFill>
-              </a:rPr>
-              <a:t>a=999, b=1, c=1 fires P3 directly;  a=512, b=256, c=768 fires P4.</a:t>
-            </a:r>
-          </a:p>
-          <a:p>
-            <a:pPr>
-              <a:spcAft>
-                <a:spcPts val="800"/>
-              </a:spcAft>
-            </a:pPr>
-            <a:r>
-              <a:rPr sz="2200">
-                <a:solidFill>
-                  <a:srgbClr val="212121"/>
-                </a:solidFill>
-              </a:rPr>
-              <a:t>Fixed + specified: VERIFICATION SUCCESSFUL in ~0.5 s.</a:t>
-            </a:r>
-          </a:p>
-        </p:txBody>
-      </p:sp>
-    </p:spTree>
-  </p:cSld>
-  <p:clrMapOvr>
-    <a:masterClrMapping/>
-  </p:clrMapOvr>
-</p:sld>
-</file>
-
-<file path=ppt/slides/slide9.xml><?xml version="1.0" encoding="utf-8"?>
-<p:sld xmlns:a="http://schemas.openxmlformats.org/drawingml/2006/main" xmlns:p="http://schemas.openxmlformats.org/presentationml/2006/main" xmlns:r="http://schemas.openxmlformats.org/officeDocument/2006/relationships">
-  <p:cSld>
-    <p:spTree>
-      <p:nvGrpSpPr>
-        <p:cNvPr id="1" name=""/>
-        <p:cNvGrpSpPr/>
-        <p:nvPr/>
-      </p:nvGrpSpPr>
-      <p:grpSpPr/>
-      <p:sp>
-        <p:nvSpPr>
-          <p:cNvPr id="2" name="TextBox 1"/>
-          <p:cNvSpPr txBox="1"/>
-          <p:nvPr/>
-        </p:nvSpPr>
-        <p:spPr>
-          <a:xfrm>
-            <a:off x="548640" y="365760"/>
-            <a:ext cx="11064240" cy="1005840"/>
-          </a:xfrm>
-          <a:prstGeom prst="rect">
-            <a:avLst/>
-          </a:prstGeom>
-          <a:noFill/>
-        </p:spPr>
-        <p:txBody>
-          <a:bodyPr wrap="square">
-            <a:spAutoFit/>
-          </a:bodyPr>
-          <a:lstStyle/>
-          <a:p>
-            <a:r>
-              <a:rPr sz="3600" b="1">
-                <a:solidFill>
-                  <a:srgbClr val="5A0A7A"/>
-                </a:solidFill>
-              </a:rPr>
               <a:t>Lab 3 — unwind.c scoreboard</a:t>
             </a:r>
           </a:p>
@@ -5836,6 +3503,2643 @@
                 </a:solidFill>
               </a:rPr>
               <a:t>The most important 5 minutes of the evening: SUCCESSFUL at 60 is a proof; FAILED at 5 says nothing about the program.</a:t>
+            </a:r>
+          </a:p>
+        </p:txBody>
+      </p:sp>
+    </p:spTree>
+  </p:cSld>
+  <p:clrMapOvr>
+    <a:masterClrMapping/>
+  </p:clrMapOvr>
+</p:sld>
+</file>
+
+<file path=ppt/slides/slide11.xml><?xml version="1.0" encoding="utf-8"?>
+<p:sld xmlns:a="http://schemas.openxmlformats.org/drawingml/2006/main" xmlns:p="http://schemas.openxmlformats.org/presentationml/2006/main" xmlns:r="http://schemas.openxmlformats.org/officeDocument/2006/relationships">
+  <p:cSld>
+    <p:spTree>
+      <p:nvGrpSpPr>
+        <p:cNvPr id="1" name=""/>
+        <p:cNvGrpSpPr/>
+        <p:nvPr/>
+      </p:nvGrpSpPr>
+      <p:grpSpPr/>
+      <p:sp>
+        <p:nvSpPr>
+          <p:cNvPr id="2" name="TextBox 1"/>
+          <p:cNvSpPr txBox="1"/>
+          <p:nvPr/>
+        </p:nvSpPr>
+        <p:spPr>
+          <a:xfrm>
+            <a:off x="548640" y="365760"/>
+            <a:ext cx="11064240" cy="1005840"/>
+          </a:xfrm>
+          <a:prstGeom prst="rect">
+            <a:avLst/>
+          </a:prstGeom>
+          <a:noFill/>
+        </p:spPr>
+        <p:txBody>
+          <a:bodyPr wrap="square">
+            <a:spAutoFit/>
+          </a:bodyPr>
+          <a:lstStyle/>
+          <a:p>
+            <a:r>
+              <a:rPr sz="3600" b="1">
+                <a:solidFill>
+                  <a:srgbClr val="5A0A7A"/>
+                </a:solidFill>
+              </a:rPr>
+              <a:t>Lab 4, Track A — race.c</a:t>
+            </a:r>
+          </a:p>
+        </p:txBody>
+      </p:sp>
+      <p:sp>
+        <p:nvSpPr>
+          <p:cNvPr id="3" name="TextBox 2"/>
+          <p:cNvSpPr txBox="1"/>
+          <p:nvPr/>
+        </p:nvSpPr>
+        <p:spPr>
+          <a:xfrm>
+            <a:off x="731520" y="1463040"/>
+            <a:ext cx="10789920" cy="5120640"/>
+          </a:xfrm>
+          <a:prstGeom prst="rect">
+            <a:avLst/>
+          </a:prstGeom>
+          <a:noFill/>
+        </p:spPr>
+        <p:txBody>
+          <a:bodyPr wrap="square">
+            <a:spAutoFit/>
+          </a:bodyPr>
+          <a:lstStyle/>
+          <a:p>
+            <a:pPr>
+              <a:spcAft>
+                <a:spcPts val="800"/>
+              </a:spcAft>
+            </a:pPr>
+            <a:r>
+              <a:rPr sz="2200">
+                <a:solidFill>
+                  <a:srgbClr val="212121"/>
+                </a:solidFill>
+              </a:rPr>
+              <a:t>The failing interleaving, straight from the trace:</a:t>
+            </a:r>
+          </a:p>
+          <a:p>
+            <a:pPr lvl="1">
+              <a:spcAft>
+                <a:spcPts val="0"/>
+              </a:spcAft>
+            </a:pPr>
+            <a:r>
+              <a:rPr sz="1800">
+                <a:solidFill>
+                  <a:srgbClr val="212121"/>
+                </a:solidFill>
+                <a:latin typeface="Courier New"/>
+              </a:rPr>
+              <a:t>State 71 ... function t1 thread 1      g = 1</a:t>
+            </a:r>
+          </a:p>
+          <a:p>
+            <a:pPr lvl="1">
+              <a:spcAft>
+                <a:spcPts val="0"/>
+              </a:spcAft>
+            </a:pPr>
+            <a:r>
+              <a:rPr sz="1800">
+                <a:solidFill>
+                  <a:srgbClr val="212121"/>
+                </a:solidFill>
+                <a:latin typeface="Courier New"/>
+              </a:rPr>
+              <a:t>State 78 ... function t2 thread 2      g = 2</a:t>
+            </a:r>
+          </a:p>
+          <a:p>
+            <a:pPr lvl="1">
+              <a:spcAft>
+                <a:spcPts val="0"/>
+              </a:spcAft>
+            </a:pPr>
+            <a:r>
+              <a:rPr sz="1800">
+                <a:solidFill>
+                  <a:srgbClr val="212121"/>
+                </a:solidFill>
+                <a:latin typeface="Courier New"/>
+              </a:rPr>
+              <a:t>State 87 ... function t1 thread 1</a:t>
+            </a:r>
+          </a:p>
+          <a:p>
+            <a:pPr lvl="1">
+              <a:spcAft>
+                <a:spcPts val="0"/>
+              </a:spcAft>
+            </a:pPr>
+            <a:r>
+              <a:rPr sz="1800">
+                <a:solidFill>
+                  <a:srgbClr val="212121"/>
+                </a:solidFill>
+                <a:latin typeface="Courier New"/>
+              </a:rPr>
+              <a:t>Violated property: assertion t1   (g == 1)</a:t>
+            </a:r>
+          </a:p>
+          <a:p>
+            <a:pPr>
+              <a:spcAft>
+                <a:spcPts val="800"/>
+              </a:spcAft>
+            </a:pPr>
+            <a:r>
+              <a:rPr sz="2200">
+                <a:solidFill>
+                  <a:srgbClr val="212121"/>
+                </a:solidFill>
+              </a:rPr>
+              <a:t/>
+            </a:r>
+          </a:p>
+          <a:p>
+            <a:pPr>
+              <a:spcAft>
+                <a:spcPts val="800"/>
+              </a:spcAft>
+            </a:pPr>
+            <a:r>
+              <a:rPr sz="2200">
+                <a:solidFill>
+                  <a:srgbClr val="212121"/>
+                </a:solidFill>
+              </a:rPr>
+              <a:t>Fix (race_fixed.c): one mutex makes write-then-check atomic — lock around g = 1; assert(g == 1); in t1 and around g = 2 in t2.</a:t>
+            </a:r>
+          </a:p>
+          <a:p>
+            <a:pPr lvl="1">
+              <a:spcAft>
+                <a:spcPts val="0"/>
+              </a:spcAft>
+            </a:pPr>
+            <a:r>
+              <a:rPr sz="1800">
+                <a:solidFill>
+                  <a:srgbClr val="212121"/>
+                </a:solidFill>
+                <a:latin typeface="Courier New"/>
+              </a:rPr>
+              <a:t>esbmc race_fixed.c --context-bound 2  =&gt;  SUCCESSFUL</a:t>
+            </a:r>
+          </a:p>
+        </p:txBody>
+      </p:sp>
+    </p:spTree>
+  </p:cSld>
+  <p:clrMapOvr>
+    <a:masterClrMapping/>
+  </p:clrMapOvr>
+</p:sld>
+</file>
+
+<file path=ppt/slides/slide12.xml><?xml version="1.0" encoding="utf-8"?>
+<p:sld xmlns:a="http://schemas.openxmlformats.org/drawingml/2006/main" xmlns:p="http://schemas.openxmlformats.org/presentationml/2006/main" xmlns:r="http://schemas.openxmlformats.org/officeDocument/2006/relationships">
+  <p:cSld>
+    <p:spTree>
+      <p:nvGrpSpPr>
+        <p:cNvPr id="1" name=""/>
+        <p:cNvGrpSpPr/>
+        <p:nvPr/>
+      </p:nvGrpSpPr>
+      <p:grpSpPr/>
+      <p:sp>
+        <p:nvSpPr>
+          <p:cNvPr id="2" name="TextBox 1"/>
+          <p:cNvSpPr txBox="1"/>
+          <p:nvPr/>
+        </p:nvSpPr>
+        <p:spPr>
+          <a:xfrm>
+            <a:off x="548640" y="365760"/>
+            <a:ext cx="11064240" cy="1005840"/>
+          </a:xfrm>
+          <a:prstGeom prst="rect">
+            <a:avLst/>
+          </a:prstGeom>
+          <a:noFill/>
+        </p:spPr>
+        <p:txBody>
+          <a:bodyPr wrap="square">
+            <a:spAutoFit/>
+          </a:bodyPr>
+          <a:lstStyle/>
+          <a:p>
+            <a:r>
+              <a:rPr sz="3600" b="1">
+                <a:solidFill>
+                  <a:srgbClr val="5A0A7A"/>
+                </a:solidFill>
+              </a:rPr>
+              <a:t>Lab 4, Track B — float.c</a:t>
+            </a:r>
+          </a:p>
+        </p:txBody>
+      </p:sp>
+      <p:sp>
+        <p:nvSpPr>
+          <p:cNvPr id="3" name="TextBox 2"/>
+          <p:cNvSpPr txBox="1"/>
+          <p:nvPr/>
+        </p:nvSpPr>
+        <p:spPr>
+          <a:xfrm>
+            <a:off x="731520" y="1463040"/>
+            <a:ext cx="10789920" cy="5120640"/>
+          </a:xfrm>
+          <a:prstGeom prst="rect">
+            <a:avLst/>
+          </a:prstGeom>
+          <a:noFill/>
+        </p:spPr>
+        <p:txBody>
+          <a:bodyPr wrap="square">
+            <a:spAutoFit/>
+          </a:bodyPr>
+          <a:lstStyle/>
+          <a:p>
+            <a:pPr>
+              <a:spcAft>
+                <a:spcPts val="800"/>
+              </a:spcAft>
+            </a:pPr>
+            <a:r>
+              <a:rPr sz="2200">
+                <a:solidFill>
+                  <a:srgbClr val="212121"/>
+                </a:solidFill>
+              </a:rPr>
+              <a:t>FAILED is the correct verdict — the program is genuinely wrong.</a:t>
+            </a:r>
+          </a:p>
+          <a:p>
+            <a:pPr lvl="1">
+              <a:spcAft>
+                <a:spcPts val="800"/>
+              </a:spcAft>
+            </a:pPr>
+            <a:r>
+              <a:rPr sz="2000">
+                <a:solidFill>
+                  <a:srgbClr val="212121"/>
+                </a:solidFill>
+              </a:rPr>
+              <a:t>0.1, 0.2 and 0.3 have no exact binary64 representation — same reason 1/3 has none in decimal.</a:t>
+            </a:r>
+          </a:p>
+          <a:p>
+            <a:pPr lvl="1">
+              <a:spcAft>
+                <a:spcPts val="800"/>
+              </a:spcAft>
+            </a:pPr>
+            <a:r>
+              <a:rPr sz="2000">
+                <a:solidFill>
+                  <a:srgbClr val="212121"/>
+                </a:solidFill>
+              </a:rPr>
+              <a:t>0.1 + 0.2 rounds to the double nearest 0.30000000000000004, which is not the double nearest 0.3.</a:t>
+            </a:r>
+          </a:p>
+          <a:p>
+            <a:pPr>
+              <a:spcAft>
+                <a:spcPts val="800"/>
+              </a:spcAft>
+            </a:pPr>
+            <a:r>
+              <a:rPr sz="2200">
+                <a:solidFill>
+                  <a:srgbClr val="212121"/>
+                </a:solidFill>
+              </a:rPr>
+              <a:t/>
+            </a:r>
+          </a:p>
+          <a:p>
+            <a:pPr>
+              <a:spcAft>
+                <a:spcPts val="800"/>
+              </a:spcAft>
+            </a:pPr>
+            <a:r>
+              <a:rPr sz="2200">
+                <a:solidFill>
+                  <a:srgbClr val="212121"/>
+                </a:solidFill>
+              </a:rPr>
+              <a:t>There is no float_fixed.c — by design. Discuss the remedies:</a:t>
+            </a:r>
+          </a:p>
+          <a:p>
+            <a:pPr lvl="1">
+              <a:spcAft>
+                <a:spcPts val="0"/>
+              </a:spcAft>
+            </a:pPr>
+            <a:r>
+              <a:rPr sz="1800">
+                <a:solidFill>
+                  <a:srgbClr val="212121"/>
+                </a:solidFill>
+                <a:latin typeface="Courier New"/>
+              </a:rPr>
+              <a:t>compare with an epsilon: fabs(w - z) &lt; 1e-9</a:t>
+            </a:r>
+          </a:p>
+          <a:p>
+            <a:pPr lvl="1">
+              <a:spcAft>
+                <a:spcPts val="800"/>
+              </a:spcAft>
+            </a:pPr>
+            <a:r>
+              <a:rPr sz="2000">
+                <a:solidFill>
+                  <a:srgbClr val="212121"/>
+                </a:solidFill>
+              </a:rPr>
+              <a:t>use decimal / fixed-point where exactness matters (money!)</a:t>
+            </a:r>
+          </a:p>
+          <a:p>
+            <a:pPr lvl="1">
+              <a:spcAft>
+                <a:spcPts val="800"/>
+              </a:spcAft>
+            </a:pPr>
+            <a:r>
+              <a:rPr sz="2000">
+                <a:solidFill>
+                  <a:srgbClr val="212121"/>
+                </a:solidFill>
+              </a:rPr>
+              <a:t>or specify the property you actually mean.</a:t>
+            </a:r>
+          </a:p>
+        </p:txBody>
+      </p:sp>
+    </p:spTree>
+  </p:cSld>
+  <p:clrMapOvr>
+    <a:masterClrMapping/>
+  </p:clrMapOvr>
+</p:sld>
+</file>
+
+<file path=ppt/slides/slide13.xml><?xml version="1.0" encoding="utf-8"?>
+<p:sld xmlns:a="http://schemas.openxmlformats.org/drawingml/2006/main" xmlns:p="http://schemas.openxmlformats.org/presentationml/2006/main" xmlns:r="http://schemas.openxmlformats.org/officeDocument/2006/relationships">
+  <p:cSld>
+    <p:spTree>
+      <p:nvGrpSpPr>
+        <p:cNvPr id="1" name=""/>
+        <p:cNvGrpSpPr/>
+        <p:nvPr/>
+      </p:nvGrpSpPr>
+      <p:grpSpPr/>
+      <p:sp>
+        <p:nvSpPr>
+          <p:cNvPr id="2" name="TextBox 1"/>
+          <p:cNvSpPr txBox="1"/>
+          <p:nvPr/>
+        </p:nvSpPr>
+        <p:spPr>
+          <a:xfrm>
+            <a:off x="548640" y="365760"/>
+            <a:ext cx="11064240" cy="1005840"/>
+          </a:xfrm>
+          <a:prstGeom prst="rect">
+            <a:avLst/>
+          </a:prstGeom>
+          <a:noFill/>
+        </p:spPr>
+        <p:txBody>
+          <a:bodyPr wrap="square">
+            <a:spAutoFit/>
+          </a:bodyPr>
+          <a:lstStyle/>
+          <a:p>
+            <a:r>
+              <a:rPr sz="3600" b="1">
+                <a:solidFill>
+                  <a:srgbClr val="5A0A7A"/>
+                </a:solidFill>
+              </a:rPr>
+              <a:t>Master verdict table (fallback if live demos die)</a:t>
+            </a:r>
+          </a:p>
+        </p:txBody>
+      </p:sp>
+      <p:graphicFrame>
+        <p:nvGraphicFramePr>
+          <p:cNvPr id="3" name="Table 2"/>
+          <p:cNvGraphicFramePr>
+            <a:graphicFrameLocks noGrp="1"/>
+          </p:cNvGraphicFramePr>
+          <p:nvPr/>
+        </p:nvGraphicFramePr>
+        <p:xfrm>
+          <a:off x="731520" y="1371600"/>
+          <a:ext cx="10698480" cy="4023360"/>
+        </p:xfrm>
+        <a:graphic>
+          <a:graphicData uri="http://schemas.openxmlformats.org/drawingml/2006/table">
+            <a:tbl>
+              <a:tblPr firstRow="1" bandRow="1">
+                <a:tableStyleId>{5C22544A-7EE6-4342-B048-85BDC9FD1C3A}</a:tableStyleId>
+              </a:tblPr>
+              <a:tblGrid>
+                <a:gridCol w="1737360"/>
+                <a:gridCol w="4206240"/>
+                <a:gridCol w="2651760"/>
+                <a:gridCol w="2103120"/>
+              </a:tblGrid>
+              <a:tr h="365760">
+                <a:tc>
+                  <a:txBody>
+                    <a:bodyPr/>
+                    <a:lstStyle/>
+                    <a:p>
+                      <a:r>
+                        <a:rPr sz="1200" b="1"/>
+                        <a:t>File</a:t>
+                      </a:r>
+                    </a:p>
+                  </a:txBody>
+                  <a:tcPr/>
+                </a:tc>
+                <a:tc>
+                  <a:txBody>
+                    <a:bodyPr/>
+                    <a:lstStyle/>
+                    <a:p>
+                      <a:r>
+                        <a:rPr sz="1200" b="1"/>
+                        <a:t>Command</a:t>
+                      </a:r>
+                    </a:p>
+                  </a:txBody>
+                  <a:tcPr/>
+                </a:tc>
+                <a:tc>
+                  <a:txBody>
+                    <a:bodyPr/>
+                    <a:lstStyle/>
+                    <a:p>
+                      <a:r>
+                        <a:rPr sz="1200" b="1"/>
+                        <a:t>Buggy</a:t>
+                      </a:r>
+                    </a:p>
+                  </a:txBody>
+                  <a:tcPr/>
+                </a:tc>
+                <a:tc>
+                  <a:txBody>
+                    <a:bodyPr/>
+                    <a:lstStyle/>
+                    <a:p>
+                      <a:r>
+                        <a:rPr sz="1200" b="1"/>
+                        <a:t>Fixed</a:t>
+                      </a:r>
+                    </a:p>
+                  </a:txBody>
+                  <a:tcPr/>
+                </a:tc>
+              </a:tr>
+              <a:tr h="365760">
+                <a:tc>
+                  <a:txBody>
+                    <a:bodyPr/>
+                    <a:lstStyle/>
+                    <a:p>
+                      <a:r>
+                        <a:rPr sz="1200"/>
+                        <a:t>overflow.c</a:t>
+                      </a:r>
+                    </a:p>
+                  </a:txBody>
+                  <a:tcPr/>
+                </a:tc>
+                <a:tc>
+                  <a:txBody>
+                    <a:bodyPr/>
+                    <a:lstStyle/>
+                    <a:p>
+                      <a:r>
+                        <a:rPr sz="1200"/>
+                        <a:t>esbmc overflow.c</a:t>
+                      </a:r>
+                    </a:p>
+                  </a:txBody>
+                  <a:tcPr/>
+                </a:tc>
+                <a:tc>
+                  <a:txBody>
+                    <a:bodyPr/>
+                    <a:lstStyle/>
+                    <a:p>
+                      <a:r>
+                        <a:rPr sz="1200"/>
+                        <a:t>FAILED</a:t>
+                      </a:r>
+                    </a:p>
+                  </a:txBody>
+                  <a:tcPr/>
+                </a:tc>
+                <a:tc>
+                  <a:txBody>
+                    <a:bodyPr/>
+                    <a:lstStyle/>
+                    <a:p>
+                      <a:r>
+                        <a:rPr sz="1200"/>
+                        <a:t>SUCCESSFUL</a:t>
+                      </a:r>
+                    </a:p>
+                  </a:txBody>
+                  <a:tcPr/>
+                </a:tc>
+              </a:tr>
+              <a:tr h="365760">
+                <a:tc>
+                  <a:txBody>
+                    <a:bodyPr/>
+                    <a:lstStyle/>
+                    <a:p>
+                      <a:r>
+                        <a:rPr sz="1200"/>
+                        <a:t>leak.c</a:t>
+                      </a:r>
+                    </a:p>
+                  </a:txBody>
+                  <a:tcPr/>
+                </a:tc>
+                <a:tc>
+                  <a:txBody>
+                    <a:bodyPr/>
+                    <a:lstStyle/>
+                    <a:p>
+                      <a:r>
+                        <a:rPr sz="1200"/>
+                        <a:t>esbmc leak.c --memory-leak-check</a:t>
+                      </a:r>
+                    </a:p>
+                  </a:txBody>
+                  <a:tcPr/>
+                </a:tc>
+                <a:tc>
+                  <a:txBody>
+                    <a:bodyPr/>
+                    <a:lstStyle/>
+                    <a:p>
+                      <a:r>
+                        <a:rPr sz="1200"/>
+                        <a:t>FAILED</a:t>
+                      </a:r>
+                    </a:p>
+                  </a:txBody>
+                  <a:tcPr/>
+                </a:tc>
+                <a:tc>
+                  <a:txBody>
+                    <a:bodyPr/>
+                    <a:lstStyle/>
+                    <a:p>
+                      <a:r>
+                        <a:rPr sz="1200"/>
+                        <a:t>SUCCESSFUL</a:t>
+                      </a:r>
+                    </a:p>
+                  </a:txBody>
+                  <a:tcPr/>
+                </a:tc>
+              </a:tr>
+              <a:tr h="365760">
+                <a:tc>
+                  <a:txBody>
+                    <a:bodyPr/>
+                    <a:lstStyle/>
+                    <a:p>
+                      <a:r>
+                        <a:rPr sz="1200"/>
+                        <a:t>vla.c</a:t>
+                      </a:r>
+                    </a:p>
+                  </a:txBody>
+                  <a:tcPr/>
+                </a:tc>
+                <a:tc>
+                  <a:txBody>
+                    <a:bodyPr/>
+                    <a:lstStyle/>
+                    <a:p>
+                      <a:r>
+                        <a:rPr sz="1200"/>
+                        <a:t>esbmc vla.c --unwind 6</a:t>
+                      </a:r>
+                    </a:p>
+                  </a:txBody>
+                  <a:tcPr/>
+                </a:tc>
+                <a:tc>
+                  <a:txBody>
+                    <a:bodyPr/>
+                    <a:lstStyle/>
+                    <a:p>
+                      <a:r>
+                        <a:rPr sz="1200"/>
+                        <a:t>FAILED</a:t>
+                      </a:r>
+                    </a:p>
+                  </a:txBody>
+                  <a:tcPr/>
+                </a:tc>
+                <a:tc>
+                  <a:txBody>
+                    <a:bodyPr/>
+                    <a:lstStyle/>
+                    <a:p>
+                      <a:r>
+                        <a:rPr sz="1200"/>
+                        <a:t>SUCCESSFUL</a:t>
+                      </a:r>
+                    </a:p>
+                  </a:txBody>
+                  <a:tcPr/>
+                </a:tc>
+              </a:tr>
+              <a:tr h="365760">
+                <a:tc>
+                  <a:txBody>
+                    <a:bodyPr/>
+                    <a:lstStyle/>
+                    <a:p>
+                      <a:r>
+                        <a:rPr sz="1200"/>
+                        <a:t>getpassword.c</a:t>
+                      </a:r>
+                    </a:p>
+                  </a:txBody>
+                  <a:tcPr/>
+                </a:tc>
+                <a:tc>
+                  <a:txBody>
+                    <a:bodyPr/>
+                    <a:lstStyle/>
+                    <a:p>
+                      <a:r>
+                        <a:rPr sz="1200"/>
+                        <a:t>esbmc getpassword.c --unwind 8</a:t>
+                      </a:r>
+                    </a:p>
+                  </a:txBody>
+                  <a:tcPr/>
+                </a:tc>
+                <a:tc>
+                  <a:txBody>
+                    <a:bodyPr/>
+                    <a:lstStyle/>
+                    <a:p>
+                      <a:r>
+                        <a:rPr sz="1200"/>
+                        <a:t>FAILED</a:t>
+                      </a:r>
+                    </a:p>
+                  </a:txBody>
+                  <a:tcPr/>
+                </a:tc>
+                <a:tc>
+                  <a:txBody>
+                    <a:bodyPr/>
+                    <a:lstStyle/>
+                    <a:p>
+                      <a:r>
+                        <a:rPr sz="1200"/>
+                        <a:t>SUCCESSFUL (--unwind 10)</a:t>
+                      </a:r>
+                    </a:p>
+                  </a:txBody>
+                  <a:tcPr/>
+                </a:tc>
+              </a:tr>
+              <a:tr h="365760">
+                <a:tc>
+                  <a:txBody>
+                    <a:bodyPr/>
+                    <a:lstStyle/>
+                    <a:p>
+                      <a:r>
+                        <a:rPr sz="1200"/>
+                        <a:t>triangle.c</a:t>
+                      </a:r>
+                    </a:p>
+                  </a:txBody>
+                  <a:tcPr/>
+                </a:tc>
+                <a:tc>
+                  <a:txBody>
+                    <a:bodyPr/>
+                    <a:lstStyle/>
+                    <a:p>
+                      <a:r>
+                        <a:rPr sz="1200"/>
+                        <a:t>esbmc triangle.c</a:t>
+                      </a:r>
+                    </a:p>
+                  </a:txBody>
+                  <a:tcPr/>
+                </a:tc>
+                <a:tc>
+                  <a:txBody>
+                    <a:bodyPr/>
+                    <a:lstStyle/>
+                    <a:p>
+                      <a:r>
+                        <a:rPr sz="1200"/>
+                        <a:t>SUCCESSFUL (weak spec!)</a:t>
+                      </a:r>
+                    </a:p>
+                  </a:txBody>
+                  <a:tcPr/>
+                </a:tc>
+                <a:tc>
+                  <a:txBody>
+                    <a:bodyPr/>
+                    <a:lstStyle/>
+                    <a:p>
+                      <a:r>
+                        <a:rPr sz="1200"/>
+                        <a:t>SUCCESSFUL (full spec)</a:t>
+                      </a:r>
+                    </a:p>
+                  </a:txBody>
+                  <a:tcPr/>
+                </a:tc>
+              </a:tr>
+              <a:tr h="365760">
+                <a:tc>
+                  <a:txBody>
+                    <a:bodyPr/>
+                    <a:lstStyle/>
+                    <a:p>
+                      <a:r>
+                        <a:rPr sz="1200"/>
+                        <a:t>unwind.c</a:t>
+                      </a:r>
+                    </a:p>
+                  </a:txBody>
+                  <a:tcPr/>
+                </a:tc>
+                <a:tc>
+                  <a:txBody>
+                    <a:bodyPr/>
+                    <a:lstStyle/>
+                    <a:p>
+                      <a:r>
+                        <a:rPr sz="1200"/>
+                        <a:t>--unwind 5 / 20 / 60 / --k-induction</a:t>
+                      </a:r>
+                    </a:p>
+                  </a:txBody>
+                  <a:tcPr/>
+                </a:tc>
+                <a:tc>
+                  <a:txBody>
+                    <a:bodyPr/>
+                    <a:lstStyle/>
+                    <a:p>
+                      <a:r>
+                        <a:rPr sz="1200"/>
+                        <a:t>F / F / S / UNKNOWN</a:t>
+                      </a:r>
+                    </a:p>
+                  </a:txBody>
+                  <a:tcPr/>
+                </a:tc>
+                <a:tc>
+                  <a:txBody>
+                    <a:bodyPr/>
+                    <a:lstStyle/>
+                    <a:p>
+                      <a:r>
+                        <a:rPr sz="1200"/>
+                        <a:t>—</a:t>
+                      </a:r>
+                    </a:p>
+                  </a:txBody>
+                  <a:tcPr/>
+                </a:tc>
+              </a:tr>
+              <a:tr h="365760">
+                <a:tc>
+                  <a:txBody>
+                    <a:bodyPr/>
+                    <a:lstStyle/>
+                    <a:p>
+                      <a:r>
+                        <a:rPr sz="1200"/>
+                        <a:t>race.c</a:t>
+                      </a:r>
+                    </a:p>
+                  </a:txBody>
+                  <a:tcPr/>
+                </a:tc>
+                <a:tc>
+                  <a:txBody>
+                    <a:bodyPr/>
+                    <a:lstStyle/>
+                    <a:p>
+                      <a:r>
+                        <a:rPr sz="1200"/>
+                        <a:t>esbmc race.c --context-bound 2</a:t>
+                      </a:r>
+                    </a:p>
+                  </a:txBody>
+                  <a:tcPr/>
+                </a:tc>
+                <a:tc>
+                  <a:txBody>
+                    <a:bodyPr/>
+                    <a:lstStyle/>
+                    <a:p>
+                      <a:r>
+                        <a:rPr sz="1200"/>
+                        <a:t>FAILED</a:t>
+                      </a:r>
+                    </a:p>
+                  </a:txBody>
+                  <a:tcPr/>
+                </a:tc>
+                <a:tc>
+                  <a:txBody>
+                    <a:bodyPr/>
+                    <a:lstStyle/>
+                    <a:p>
+                      <a:r>
+                        <a:rPr sz="1200"/>
+                        <a:t>SUCCESSFUL</a:t>
+                      </a:r>
+                    </a:p>
+                  </a:txBody>
+                  <a:tcPr/>
+                </a:tc>
+              </a:tr>
+              <a:tr h="365760">
+                <a:tc>
+                  <a:txBody>
+                    <a:bodyPr/>
+                    <a:lstStyle/>
+                    <a:p>
+                      <a:r>
+                        <a:rPr sz="1200"/>
+                        <a:t>float.c</a:t>
+                      </a:r>
+                    </a:p>
+                  </a:txBody>
+                  <a:tcPr/>
+                </a:tc>
+                <a:tc>
+                  <a:txBody>
+                    <a:bodyPr/>
+                    <a:lstStyle/>
+                    <a:p>
+                      <a:r>
+                        <a:rPr sz="1200"/>
+                        <a:t>esbmc float.c</a:t>
+                      </a:r>
+                    </a:p>
+                  </a:txBody>
+                  <a:tcPr/>
+                </a:tc>
+                <a:tc>
+                  <a:txBody>
+                    <a:bodyPr/>
+                    <a:lstStyle/>
+                    <a:p>
+                      <a:r>
+                        <a:rPr sz="1200"/>
+                        <a:t>FAILED</a:t>
+                      </a:r>
+                    </a:p>
+                  </a:txBody>
+                  <a:tcPr/>
+                </a:tc>
+                <a:tc>
+                  <a:txBody>
+                    <a:bodyPr/>
+                    <a:lstStyle/>
+                    <a:p>
+                      <a:r>
+                        <a:rPr sz="1200"/>
+                        <a:t>— (by design)</a:t>
+                      </a:r>
+                    </a:p>
+                  </a:txBody>
+                  <a:tcPr/>
+                </a:tc>
+              </a:tr>
+              <a:tr h="365760">
+                <a:tc>
+                  <a:txBody>
+                    <a:bodyPr/>
+                    <a:lstStyle/>
+                    <a:p>
+                      <a:r>
+                        <a:rPr sz="1200"/>
+                        <a:t>stage3_esbmc.py</a:t>
+                      </a:r>
+                    </a:p>
+                  </a:txBody>
+                  <a:tcPr/>
+                </a:tc>
+                <a:tc>
+                  <a:txBody>
+                    <a:bodyPr/>
+                    <a:lstStyle/>
+                    <a:p>
+                      <a:r>
+                        <a:rPr sz="1200"/>
+                        <a:t>esbmc stage3_esbmc.py</a:t>
+                      </a:r>
+                    </a:p>
+                  </a:txBody>
+                  <a:tcPr/>
+                </a:tc>
+                <a:tc>
+                  <a:txBody>
+                    <a:bodyPr/>
+                    <a:lstStyle/>
+                    <a:p>
+                      <a:r>
+                        <a:rPr sz="1200"/>
+                        <a:t>FAILED</a:t>
+                      </a:r>
+                    </a:p>
+                  </a:txBody>
+                  <a:tcPr/>
+                </a:tc>
+                <a:tc>
+                  <a:txBody>
+                    <a:bodyPr/>
+                    <a:lstStyle/>
+                    <a:p>
+                      <a:r>
+                        <a:rPr sz="1200"/>
+                        <a:t>— (Box B)</a:t>
+                      </a:r>
+                    </a:p>
+                  </a:txBody>
+                  <a:tcPr/>
+                </a:tc>
+              </a:tr>
+              <a:tr h="365760">
+                <a:tc>
+                  <a:txBody>
+                    <a:bodyPr/>
+                    <a:lstStyle/>
+                    <a:p>
+                      <a:r>
+                        <a:rPr sz="1200"/>
+                        <a:t>safe_div.py</a:t>
+                      </a:r>
+                    </a:p>
+                  </a:txBody>
+                  <a:tcPr/>
+                </a:tc>
+                <a:tc>
+                  <a:txBody>
+                    <a:bodyPr/>
+                    <a:lstStyle/>
+                    <a:p>
+                      <a:r>
+                        <a:rPr sz="1200"/>
+                        <a:t>esbmc safe_div.py</a:t>
+                      </a:r>
+                    </a:p>
+                  </a:txBody>
+                  <a:tcPr/>
+                </a:tc>
+                <a:tc>
+                  <a:txBody>
+                    <a:bodyPr/>
+                    <a:lstStyle/>
+                    <a:p>
+                      <a:r>
+                        <a:rPr sz="1200"/>
+                        <a:t>FAILED</a:t>
+                      </a:r>
+                    </a:p>
+                  </a:txBody>
+                  <a:tcPr/>
+                </a:tc>
+                <a:tc>
+                  <a:txBody>
+                    <a:bodyPr/>
+                    <a:lstStyle/>
+                    <a:p>
+                      <a:r>
+                        <a:rPr sz="1200"/>
+                        <a:t>SUCCESSFUL (assume b!=0)</a:t>
+                      </a:r>
+                    </a:p>
+                  </a:txBody>
+                  <a:tcPr/>
+                </a:tc>
+              </a:tr>
+            </a:tbl>
+          </a:graphicData>
+        </a:graphic>
+      </p:graphicFrame>
+    </p:spTree>
+  </p:cSld>
+  <p:clrMapOvr>
+    <a:masterClrMapping/>
+  </p:clrMapOvr>
+</p:sld>
+</file>
+
+<file path=ppt/slides/slide2.xml><?xml version="1.0" encoding="utf-8"?>
+<p:sld xmlns:a="http://schemas.openxmlformats.org/drawingml/2006/main" xmlns:p="http://schemas.openxmlformats.org/presentationml/2006/main" xmlns:r="http://schemas.openxmlformats.org/officeDocument/2006/relationships">
+  <p:cSld>
+    <p:spTree>
+      <p:nvGrpSpPr>
+        <p:cNvPr id="1" name=""/>
+        <p:cNvGrpSpPr/>
+        <p:nvPr/>
+      </p:nvGrpSpPr>
+      <p:grpSpPr/>
+      <p:sp>
+        <p:nvSpPr>
+          <p:cNvPr id="2" name="TextBox 1"/>
+          <p:cNvSpPr txBox="1"/>
+          <p:nvPr/>
+        </p:nvSpPr>
+        <p:spPr>
+          <a:xfrm>
+            <a:off x="548640" y="365760"/>
+            <a:ext cx="11064240" cy="1005840"/>
+          </a:xfrm>
+          <a:prstGeom prst="rect">
+            <a:avLst/>
+          </a:prstGeom>
+          <a:noFill/>
+        </p:spPr>
+        <p:txBody>
+          <a:bodyPr wrap="square">
+            <a:spAutoFit/>
+          </a:bodyPr>
+          <a:lstStyle/>
+          <a:p>
+            <a:r>
+              <a:rPr sz="3600" b="1">
+                <a:solidFill>
+                  <a:srgbClr val="5A0A7A"/>
+                </a:solidFill>
+              </a:rPr>
+              <a:t>Lab 1, Stage 1 — answers</a:t>
+            </a:r>
+          </a:p>
+        </p:txBody>
+      </p:sp>
+      <p:sp>
+        <p:nvSpPr>
+          <p:cNvPr id="3" name="TextBox 2"/>
+          <p:cNvSpPr txBox="1"/>
+          <p:nvPr/>
+        </p:nvSpPr>
+        <p:spPr>
+          <a:xfrm>
+            <a:off x="731520" y="1463040"/>
+            <a:ext cx="10789920" cy="5120640"/>
+          </a:xfrm>
+          <a:prstGeom prst="rect">
+            <a:avLst/>
+          </a:prstGeom>
+          <a:noFill/>
+        </p:spPr>
+        <p:txBody>
+          <a:bodyPr wrap="square">
+            <a:spAutoFit/>
+          </a:bodyPr>
+          <a:lstStyle/>
+          <a:p>
+            <a:pPr>
+              <a:spcAft>
+                <a:spcPts val="800"/>
+              </a:spcAft>
+            </a:pPr>
+            <a:r>
+              <a:rPr sz="2200">
+                <a:solidFill>
+                  <a:srgbClr val="212121"/>
+                </a:solidFill>
+              </a:rPr>
+              <a:t>1c: NOT equivalent — counterexample [b = False].</a:t>
+            </a:r>
+          </a:p>
+          <a:p>
+            <a:pPr lvl="1">
+              <a:spcAft>
+                <a:spcPts val="800"/>
+              </a:spcAft>
+            </a:pPr>
+            <a:r>
+              <a:rPr sz="2000">
+                <a:solidFill>
+                  <a:srgbClr val="212121"/>
+                </a:solidFill>
+              </a:rPr>
+              <a:t>With b false, a → (b → a) is true but b is false.</a:t>
+            </a:r>
+          </a:p>
+          <a:p>
+            <a:pPr>
+              <a:spcAft>
+                <a:spcPts val="800"/>
+              </a:spcAft>
+            </a:pPr>
+            <a:r>
+              <a:rPr sz="2200">
+                <a:solidFill>
+                  <a:srgbClr val="212121"/>
+                </a:solidFill>
+              </a:rPr>
+              <a:t/>
+            </a:r>
+          </a:p>
+          <a:p>
+            <a:pPr>
+              <a:spcAft>
+                <a:spcPts val="800"/>
+              </a:spcAft>
+            </a:pPr>
+            <a:r>
+              <a:rPr sz="2200">
+                <a:solidFill>
+                  <a:srgbClr val="212121"/>
+                </a:solidFill>
+              </a:rPr>
+              <a:t>1d (the TODO): implication is NOT associative.</a:t>
+            </a:r>
+          </a:p>
+          <a:p>
+            <a:pPr lvl="1">
+              <a:spcAft>
+                <a:spcPts val="0"/>
+              </a:spcAft>
+            </a:pPr>
+            <a:r>
+              <a:rPr sz="1800">
+                <a:solidFill>
+                  <a:srgbClr val="212121"/>
+                </a:solidFill>
+                <a:latin typeface="Courier New"/>
+              </a:rPr>
+              <a:t>equivalent(Implies(Implies(a, b), c),</a:t>
+            </a:r>
+          </a:p>
+          <a:p>
+            <a:pPr lvl="1">
+              <a:spcAft>
+                <a:spcPts val="0"/>
+              </a:spcAft>
+            </a:pPr>
+            <a:r>
+              <a:rPr sz="1800">
+                <a:solidFill>
+                  <a:srgbClr val="212121"/>
+                </a:solidFill>
+                <a:latin typeface="Courier New"/>
+              </a:rPr>
+              <a:t>           Implies(a, Implies(b, c)), "1d")</a:t>
+            </a:r>
+          </a:p>
+          <a:p>
+            <a:pPr lvl="1">
+              <a:spcAft>
+                <a:spcPts val="800"/>
+              </a:spcAft>
+            </a:pPr>
+            <a:r>
+              <a:rPr sz="2000">
+                <a:solidFill>
+                  <a:srgbClr val="212121"/>
+                </a:solidFill>
+              </a:rPr>
+              <a:t>Counterexample: a and c both false — lhs is false (T → F), rhs is true (F → anything).</a:t>
+            </a:r>
+          </a:p>
+        </p:txBody>
+      </p:sp>
+    </p:spTree>
+  </p:cSld>
+  <p:clrMapOvr>
+    <a:masterClrMapping/>
+  </p:clrMapOvr>
+</p:sld>
+</file>
+
+<file path=ppt/slides/slide3.xml><?xml version="1.0" encoding="utf-8"?>
+<p:sld xmlns:a="http://schemas.openxmlformats.org/drawingml/2006/main" xmlns:p="http://schemas.openxmlformats.org/presentationml/2006/main" xmlns:r="http://schemas.openxmlformats.org/officeDocument/2006/relationships">
+  <p:cSld>
+    <p:spTree>
+      <p:nvGrpSpPr>
+        <p:cNvPr id="1" name=""/>
+        <p:cNvGrpSpPr/>
+        <p:nvPr/>
+      </p:nvGrpSpPr>
+      <p:grpSpPr/>
+      <p:sp>
+        <p:nvSpPr>
+          <p:cNvPr id="2" name="TextBox 1"/>
+          <p:cNvSpPr txBox="1"/>
+          <p:nvPr/>
+        </p:nvSpPr>
+        <p:spPr>
+          <a:xfrm>
+            <a:off x="548640" y="365760"/>
+            <a:ext cx="11064240" cy="1005840"/>
+          </a:xfrm>
+          <a:prstGeom prst="rect">
+            <a:avLst/>
+          </a:prstGeom>
+          <a:noFill/>
+        </p:spPr>
+        <p:txBody>
+          <a:bodyPr wrap="square">
+            <a:spAutoFit/>
+          </a:bodyPr>
+          <a:lstStyle/>
+          <a:p>
+            <a:r>
+              <a:rPr sz="3600" b="1">
+                <a:solidFill>
+                  <a:srgbClr val="5A0A7A"/>
+                </a:solidFill>
+              </a:rPr>
+              <a:t>Lab 1, Stages 2–3 — answers</a:t>
+            </a:r>
+          </a:p>
+        </p:txBody>
+      </p:sp>
+      <p:sp>
+        <p:nvSpPr>
+          <p:cNvPr id="3" name="TextBox 2"/>
+          <p:cNvSpPr txBox="1"/>
+          <p:nvPr/>
+        </p:nvSpPr>
+        <p:spPr>
+          <a:xfrm>
+            <a:off x="731520" y="1463040"/>
+            <a:ext cx="10789920" cy="5120640"/>
+          </a:xfrm>
+          <a:prstGeom prst="rect">
+            <a:avLst/>
+          </a:prstGeom>
+          <a:noFill/>
+        </p:spPr>
+        <p:txBody>
+          <a:bodyPr wrap="square">
+            <a:spAutoFit/>
+          </a:bodyPr>
+          <a:lstStyle/>
+          <a:p>
+            <a:pPr>
+              <a:spcAft>
+                <a:spcPts val="800"/>
+              </a:spcAft>
+            </a:pPr>
+            <a:r>
+              <a:rPr sz="2200">
+                <a:solidFill>
+                  <a:srgbClr val="212121"/>
+                </a:solidFill>
+              </a:rPr>
+              <a:t>Stage 2 — the missing constraint:</a:t>
+            </a:r>
+          </a:p>
+          <a:p>
+            <a:pPr lvl="1">
+              <a:spcAft>
+                <a:spcPts val="0"/>
+              </a:spcAft>
+            </a:pPr>
+            <a:r>
+              <a:rPr sz="1800">
+                <a:solidFill>
+                  <a:srgbClr val="212121"/>
+                </a:solidFill>
+                <a:latin typeface="Courier New"/>
+              </a:rPr>
+              <a:t>send  = 1000*S + 100*E + 10*N + D   (more, money alike)</a:t>
+            </a:r>
+          </a:p>
+          <a:p>
+            <a:pPr lvl="1">
+              <a:spcAft>
+                <a:spcPts val="0"/>
+              </a:spcAft>
+            </a:pPr>
+            <a:r>
+              <a:rPr sz="1800">
+                <a:solidFill>
+                  <a:srgbClr val="212121"/>
+                </a:solidFill>
+                <a:latin typeface="Courier New"/>
+              </a:rPr>
+              <a:t>s.add(send + more == money)</a:t>
+            </a:r>
+          </a:p>
+          <a:p>
+            <a:pPr lvl="1">
+              <a:spcAft>
+                <a:spcPts val="800"/>
+              </a:spcAft>
+            </a:pPr>
+            <a:r>
+              <a:rPr sz="2000">
+                <a:solidFill>
+                  <a:srgbClr val="212121"/>
+                </a:solidFill>
+              </a:rPr>
+              <a:t>Unique model: 9567 + 1085 = 10652</a:t>
+            </a:r>
+          </a:p>
+          <a:p>
+            <a:pPr>
+              <a:spcAft>
+                <a:spcPts val="800"/>
+              </a:spcAft>
+            </a:pPr>
+            <a:r>
+              <a:rPr sz="2200">
+                <a:solidFill>
+                  <a:srgbClr val="212121"/>
+                </a:solidFill>
+              </a:rPr>
+              <a:t/>
+            </a:r>
+          </a:p>
+          <a:p>
+            <a:pPr>
+              <a:spcAft>
+                <a:spcPts val="800"/>
+              </a:spcAft>
+            </a:pPr>
+            <a:r>
+              <a:rPr sz="2200">
+                <a:solidFill>
+                  <a:srgbClr val="212121"/>
+                </a:solidFill>
+              </a:rPr>
+              <a:t>Stage 3, Q3 — still sat even with x &gt;= 0:</a:t>
+            </a:r>
+          </a:p>
+          <a:p>
+            <a:pPr lvl="1">
+              <a:spcAft>
+                <a:spcPts val="800"/>
+              </a:spcAft>
+            </a:pPr>
+            <a:r>
+              <a:rPr sz="2000">
+                <a:solidFill>
+                  <a:srgbClr val="212121"/>
+                </a:solidFill>
+              </a:rPr>
+              <a:t>x = 0x7FFFFFFF wraps y to INT_MIN; 2 * INT_MIN wraps to 0 &lt; 2.</a:t>
+            </a:r>
+          </a:p>
+          <a:p>
+            <a:pPr lvl="1">
+              <a:spcAft>
+                <a:spcPts val="800"/>
+              </a:spcAft>
+            </a:pPr>
+            <a:r>
+              <a:rPr sz="2000">
+                <a:solidFill>
+                  <a:srgbClr val="212121"/>
+                </a:solidFill>
+              </a:rPr>
+              <a:t>Same bug class --overflow-check hunts in Lab 2.</a:t>
+            </a:r>
+          </a:p>
+        </p:txBody>
+      </p:sp>
+    </p:spTree>
+  </p:cSld>
+  <p:clrMapOvr>
+    <a:masterClrMapping/>
+  </p:clrMapOvr>
+</p:sld>
+</file>
+
+<file path=ppt/slides/slide4.xml><?xml version="1.0" encoding="utf-8"?>
+<p:sld xmlns:a="http://schemas.openxmlformats.org/drawingml/2006/main" xmlns:p="http://schemas.openxmlformats.org/presentationml/2006/main" xmlns:r="http://schemas.openxmlformats.org/officeDocument/2006/relationships">
+  <p:cSld>
+    <p:spTree>
+      <p:nvGrpSpPr>
+        <p:cNvPr id="1" name=""/>
+        <p:cNvGrpSpPr/>
+        <p:nvPr/>
+      </p:nvGrpSpPr>
+      <p:grpSpPr/>
+      <p:sp>
+        <p:nvSpPr>
+          <p:cNvPr id="2" name="TextBox 1"/>
+          <p:cNvSpPr txBox="1"/>
+          <p:nvPr/>
+        </p:nvSpPr>
+        <p:spPr>
+          <a:xfrm>
+            <a:off x="548640" y="365760"/>
+            <a:ext cx="11064240" cy="1005840"/>
+          </a:xfrm>
+          <a:prstGeom prst="rect">
+            <a:avLst/>
+          </a:prstGeom>
+          <a:noFill/>
+        </p:spPr>
+        <p:txBody>
+          <a:bodyPr wrap="square">
+            <a:spAutoFit/>
+          </a:bodyPr>
+          <a:lstStyle/>
+          <a:p>
+            <a:r>
+              <a:rPr sz="3600" b="1">
+                <a:solidFill>
+                  <a:srgbClr val="5A0A7A"/>
+                </a:solidFill>
+              </a:rPr>
+              <a:t>Box B — ESBMC on Python (optional)</a:t>
+            </a:r>
+          </a:p>
+        </p:txBody>
+      </p:sp>
+      <p:sp>
+        <p:nvSpPr>
+          <p:cNvPr id="3" name="TextBox 2"/>
+          <p:cNvSpPr txBox="1"/>
+          <p:nvPr/>
+        </p:nvSpPr>
+        <p:spPr>
+          <a:xfrm>
+            <a:off x="731520" y="1463040"/>
+            <a:ext cx="10789920" cy="5120640"/>
+          </a:xfrm>
+          <a:prstGeom prst="rect">
+            <a:avLst/>
+          </a:prstGeom>
+          <a:noFill/>
+        </p:spPr>
+        <p:txBody>
+          <a:bodyPr wrap="square">
+            <a:spAutoFit/>
+          </a:bodyPr>
+          <a:lstStyle/>
+          <a:p>
+            <a:pPr>
+              <a:spcAft>
+                <a:spcPts val="800"/>
+              </a:spcAft>
+            </a:pPr>
+            <a:r>
+              <a:rPr sz="2200">
+                <a:solidFill>
+                  <a:srgbClr val="212121"/>
+                </a:solidFill>
+              </a:rPr>
+              <a:t>Run under esbmc, not python3 (intrinsics, not CPython names).</a:t>
+            </a:r>
+          </a:p>
+          <a:p>
+            <a:pPr>
+              <a:spcAft>
+                <a:spcPts val="800"/>
+              </a:spcAft>
+            </a:pPr>
+            <a:r>
+              <a:rPr sz="2200">
+                <a:solidFill>
+                  <a:srgbClr val="212121"/>
+                </a:solidFill>
+              </a:rPr>
+              <a:t/>
+            </a:r>
+          </a:p>
+          <a:p>
+            <a:pPr>
+              <a:spcAft>
+                <a:spcPts val="800"/>
+              </a:spcAft>
+            </a:pPr>
+            <a:r>
+              <a:rPr sz="2200">
+                <a:solidFill>
+                  <a:srgbClr val="212121"/>
+                </a:solidFill>
+              </a:rPr>
+              <a:t>stage3_esbmc.py — FAILED, assertion z &gt;= 2:</a:t>
+            </a:r>
+          </a:p>
+          <a:p>
+            <a:pPr lvl="1">
+              <a:spcAft>
+                <a:spcPts val="800"/>
+              </a:spcAft>
+            </a:pPr>
+            <a:r>
+              <a:rPr sz="2000">
+                <a:solidFill>
+                  <a:srgbClr val="212121"/>
+                </a:solidFill>
+              </a:rPr>
+              <a:t>x = 9223372036854775807 (2^63 - 1). Same overflow as Z3 Stage 3 — ESBMC models a Python int as 64-bit, so 2^63 here vs 2^30 there.</a:t>
+            </a:r>
+          </a:p>
+          <a:p>
+            <a:pPr lvl="1">
+              <a:spcAft>
+                <a:spcPts val="800"/>
+              </a:spcAft>
+            </a:pPr>
+            <a:r>
+              <a:rPr sz="2000">
+                <a:solidFill>
+                  <a:srgbClr val="212121"/>
+                </a:solidFill>
+              </a:rPr>
+              <a:t>Q2 stretch (__ESBMC_assume(x &gt;= 0)) still FAILS at the same x.</a:t>
+            </a:r>
+          </a:p>
+          <a:p>
+            <a:pPr>
+              <a:spcAft>
+                <a:spcPts val="800"/>
+              </a:spcAft>
+            </a:pPr>
+            <a:r>
+              <a:rPr sz="2200">
+                <a:solidFill>
+                  <a:srgbClr val="212121"/>
+                </a:solidFill>
+              </a:rPr>
+              <a:t/>
+            </a:r>
+          </a:p>
+          <a:p>
+            <a:pPr>
+              <a:spcAft>
+                <a:spcPts val="800"/>
+              </a:spcAft>
+            </a:pPr>
+            <a:r>
+              <a:rPr sz="2200">
+                <a:solidFill>
+                  <a:srgbClr val="212121"/>
+                </a:solidFill>
+              </a:rPr>
+              <a:t>safe_div.py — FAILED, division by zero (CWE-369), b = 0:</a:t>
+            </a:r>
+          </a:p>
+          <a:p>
+            <a:pPr lvl="1">
+              <a:spcAft>
+                <a:spcPts val="0"/>
+              </a:spcAft>
+            </a:pPr>
+            <a:r>
+              <a:rPr sz="1800">
+                <a:solidFill>
+                  <a:srgbClr val="212121"/>
+                </a:solidFill>
+                <a:latin typeface="Courier New"/>
+              </a:rPr>
+              <a:t>Fix: __ESBMC_assume(b != 0)  =&gt;  VERIFICATION SUCCESSFUL.</a:t>
+            </a:r>
+          </a:p>
+        </p:txBody>
+      </p:sp>
+    </p:spTree>
+  </p:cSld>
+  <p:clrMapOvr>
+    <a:masterClrMapping/>
+  </p:clrMapOvr>
+</p:sld>
+</file>
+
+<file path=ppt/slides/slide5.xml><?xml version="1.0" encoding="utf-8"?>
+<p:sld xmlns:a="http://schemas.openxmlformats.org/drawingml/2006/main" xmlns:p="http://schemas.openxmlformats.org/presentationml/2006/main" xmlns:r="http://schemas.openxmlformats.org/officeDocument/2006/relationships">
+  <p:cSld>
+    <p:spTree>
+      <p:nvGrpSpPr>
+        <p:cNvPr id="1" name=""/>
+        <p:cNvGrpSpPr/>
+        <p:nvPr/>
+      </p:nvGrpSpPr>
+      <p:grpSpPr/>
+      <p:sp>
+        <p:nvSpPr>
+          <p:cNvPr id="2" name="TextBox 1"/>
+          <p:cNvSpPr txBox="1"/>
+          <p:nvPr/>
+        </p:nvSpPr>
+        <p:spPr>
+          <a:xfrm>
+            <a:off x="548640" y="365760"/>
+            <a:ext cx="11064240" cy="1005840"/>
+          </a:xfrm>
+          <a:prstGeom prst="rect">
+            <a:avLst/>
+          </a:prstGeom>
+          <a:noFill/>
+        </p:spPr>
+        <p:txBody>
+          <a:bodyPr wrap="square">
+            <a:spAutoFit/>
+          </a:bodyPr>
+          <a:lstStyle/>
+          <a:p>
+            <a:r>
+              <a:rPr sz="3600" b="1">
+                <a:solidFill>
+                  <a:srgbClr val="5A0A7A"/>
+                </a:solidFill>
+              </a:rPr>
+              <a:t>Lab 2 — overflow.c</a:t>
+            </a:r>
+          </a:p>
+        </p:txBody>
+      </p:sp>
+      <p:sp>
+        <p:nvSpPr>
+          <p:cNvPr id="3" name="TextBox 2"/>
+          <p:cNvSpPr txBox="1"/>
+          <p:nvPr/>
+        </p:nvSpPr>
+        <p:spPr>
+          <a:xfrm>
+            <a:off x="731520" y="1463040"/>
+            <a:ext cx="10789920" cy="5120640"/>
+          </a:xfrm>
+          <a:prstGeom prst="rect">
+            <a:avLst/>
+          </a:prstGeom>
+          <a:noFill/>
+        </p:spPr>
+        <p:txBody>
+          <a:bodyPr wrap="square">
+            <a:spAutoFit/>
+          </a:bodyPr>
+          <a:lstStyle/>
+          <a:p>
+            <a:pPr>
+              <a:spcAft>
+                <a:spcPts val="800"/>
+              </a:spcAft>
+            </a:pPr>
+            <a:r>
+              <a:rPr sz="2200">
+                <a:solidFill>
+                  <a:srgbClr val="212121"/>
+                </a:solidFill>
+              </a:rPr>
+              <a:t>Verdict: FAILED — solver picks i = -1, x = -1; the write lands on a[0], a[1] stays garbage.</a:t>
+            </a:r>
+          </a:p>
+          <a:p>
+            <a:pPr>
+              <a:spcAft>
+                <a:spcPts val="800"/>
+              </a:spcAft>
+            </a:pPr>
+            <a:r>
+              <a:rPr sz="2200">
+                <a:solidFill>
+                  <a:srgbClr val="212121"/>
+                </a:solidFill>
+              </a:rPr>
+              <a:t/>
+            </a:r>
+          </a:p>
+          <a:p>
+            <a:pPr>
+              <a:spcAft>
+                <a:spcPts val="800"/>
+              </a:spcAft>
+            </a:pPr>
+            <a:r>
+              <a:rPr sz="2200">
+                <a:solidFill>
+                  <a:srgbClr val="212121"/>
+                </a:solidFill>
+              </a:rPr>
+              <a:t>Fix (overflow_fixed.c): repair the index AND the spec — keep x untrusted:</a:t>
+            </a:r>
+          </a:p>
+          <a:p>
+            <a:pPr lvl="1">
+              <a:spcAft>
+                <a:spcPts val="0"/>
+              </a:spcAft>
+            </a:pPr>
+            <a:r>
+              <a:rPr sz="1800">
+                <a:solidFill>
+                  <a:srgbClr val="212121"/>
+                </a:solidFill>
+                <a:latin typeface="Courier New"/>
+              </a:rPr>
+              <a:t>int a[2] = {0, 0};  int i = 0;  int x = nondet_int();</a:t>
+            </a:r>
+          </a:p>
+          <a:p>
+            <a:pPr lvl="1">
+              <a:spcAft>
+                <a:spcPts val="0"/>
+              </a:spcAft>
+            </a:pPr>
+            <a:r>
+              <a:rPr sz="1800">
+                <a:solidFill>
+                  <a:srgbClr val="212121"/>
+                </a:solidFill>
+                <a:latin typeface="Courier New"/>
+              </a:rPr>
+              <a:t>assert(x == 0 ? *(p + i) == 0 : *(p + i + 1) == 1);</a:t>
+            </a:r>
+          </a:p>
+          <a:p>
+            <a:pPr lvl="1">
+              <a:spcAft>
+                <a:spcPts val="0"/>
+              </a:spcAft>
+            </a:pPr>
+            <a:r>
+              <a:rPr sz="1800">
+                <a:solidFill>
+                  <a:srgbClr val="212121"/>
+                </a:solidFill>
+                <a:latin typeface="Courier New"/>
+              </a:rPr>
+              <a:t>esbmc overflow_fixed.c  =&gt;  VERIFICATION SUCCESSFUL</a:t>
+            </a:r>
+          </a:p>
+          <a:p>
+            <a:pPr>
+              <a:spcAft>
+                <a:spcPts val="800"/>
+              </a:spcAft>
+            </a:pPr>
+            <a:r>
+              <a:rPr sz="2200">
+                <a:solidFill>
+                  <a:srgbClr val="212121"/>
+                </a:solidFill>
+              </a:rPr>
+              <a:t/>
+            </a:r>
+          </a:p>
+          <a:p>
+            <a:pPr>
+              <a:spcAft>
+                <a:spcPts val="800"/>
+              </a:spcAft>
+            </a:pPr>
+            <a:r>
+              <a:rPr sz="2200">
+                <a:solidFill>
+                  <a:srgbClr val="212121"/>
+                </a:solidFill>
+              </a:rPr>
+              <a:t>Takeaway: fix the index and the assertion; the input stays nondet.</a:t>
+            </a:r>
+          </a:p>
+        </p:txBody>
+      </p:sp>
+    </p:spTree>
+  </p:cSld>
+  <p:clrMapOvr>
+    <a:masterClrMapping/>
+  </p:clrMapOvr>
+</p:sld>
+</file>
+
+<file path=ppt/slides/slide6.xml><?xml version="1.0" encoding="utf-8"?>
+<p:sld xmlns:a="http://schemas.openxmlformats.org/drawingml/2006/main" xmlns:p="http://schemas.openxmlformats.org/presentationml/2006/main" xmlns:r="http://schemas.openxmlformats.org/officeDocument/2006/relationships">
+  <p:cSld>
+    <p:spTree>
+      <p:nvGrpSpPr>
+        <p:cNvPr id="1" name=""/>
+        <p:cNvGrpSpPr/>
+        <p:nvPr/>
+      </p:nvGrpSpPr>
+      <p:grpSpPr/>
+      <p:sp>
+        <p:nvSpPr>
+          <p:cNvPr id="2" name="TextBox 1"/>
+          <p:cNvSpPr txBox="1"/>
+          <p:nvPr/>
+        </p:nvSpPr>
+        <p:spPr>
+          <a:xfrm>
+            <a:off x="548640" y="365760"/>
+            <a:ext cx="11064240" cy="1005840"/>
+          </a:xfrm>
+          <a:prstGeom prst="rect">
+            <a:avLst/>
+          </a:prstGeom>
+          <a:noFill/>
+        </p:spPr>
+        <p:txBody>
+          <a:bodyPr wrap="square">
+            <a:spAutoFit/>
+          </a:bodyPr>
+          <a:lstStyle/>
+          <a:p>
+            <a:r>
+              <a:rPr sz="3600" b="1">
+                <a:solidFill>
+                  <a:srgbClr val="5A0A7A"/>
+                </a:solidFill>
+              </a:rPr>
+              <a:t>Lab 2 — leak.c</a:t>
+            </a:r>
+          </a:p>
+        </p:txBody>
+      </p:sp>
+      <p:sp>
+        <p:nvSpPr>
+          <p:cNvPr id="3" name="TextBox 2"/>
+          <p:cNvSpPr txBox="1"/>
+          <p:nvPr/>
+        </p:nvSpPr>
+        <p:spPr>
+          <a:xfrm>
+            <a:off x="731520" y="1463040"/>
+            <a:ext cx="10789920" cy="5120640"/>
+          </a:xfrm>
+          <a:prstGeom prst="rect">
+            <a:avLst/>
+          </a:prstGeom>
+          <a:noFill/>
+        </p:spPr>
+        <p:txBody>
+          <a:bodyPr wrap="square">
+            <a:spAutoFit/>
+          </a:bodyPr>
+          <a:lstStyle/>
+          <a:p>
+            <a:pPr>
+              <a:spcAft>
+                <a:spcPts val="0"/>
+              </a:spcAft>
+            </a:pPr>
+            <a:r>
+              <a:rPr sz="1800">
+                <a:solidFill>
+                  <a:srgbClr val="212121"/>
+                </a:solidFill>
+                <a:latin typeface="Courier New"/>
+              </a:rPr>
+              <a:t>dereference failure: forgotten memory: dynamic_1_array</a:t>
+            </a:r>
+          </a:p>
+          <a:p>
+            <a:pPr>
+              <a:spcAft>
+                <a:spcPts val="0"/>
+              </a:spcAft>
+            </a:pPr>
+            <a:r>
+              <a:rPr sz="1800">
+                <a:solidFill>
+                  <a:srgbClr val="212121"/>
+                </a:solidFill>
+                <a:latin typeface="Courier New"/>
+              </a:rPr>
+              <a:t>CWE: CWE-401</a:t>
+            </a:r>
+          </a:p>
+          <a:p>
+            <a:pPr>
+              <a:spcAft>
+                <a:spcPts val="800"/>
+              </a:spcAft>
+            </a:pPr>
+            <a:r>
+              <a:rPr sz="2200">
+                <a:solidFill>
+                  <a:srgbClr val="212121"/>
+                </a:solidFill>
+              </a:rPr>
+              <a:t/>
+            </a:r>
+          </a:p>
+          <a:p>
+            <a:pPr>
+              <a:spcAft>
+                <a:spcPts val="800"/>
+              </a:spcAft>
+            </a:pPr>
+            <a:r>
+              <a:rPr sz="2200">
+                <a:solidFill>
+                  <a:srgbClr val="212121"/>
+                </a:solidFill>
+              </a:rPr>
+              <a:t>p = q overwrote the only pointer to the first malloc(5) — those 5 bytes can never be freed.</a:t>
+            </a:r>
+          </a:p>
+          <a:p>
+            <a:pPr>
+              <a:spcAft>
+                <a:spcPts val="800"/>
+              </a:spcAft>
+            </a:pPr>
+            <a:r>
+              <a:rPr sz="2200">
+                <a:solidFill>
+                  <a:srgbClr val="212121"/>
+                </a:solidFill>
+              </a:rPr>
+              <a:t/>
+            </a:r>
+          </a:p>
+          <a:p>
+            <a:pPr>
+              <a:spcAft>
+                <a:spcPts val="800"/>
+              </a:spcAft>
+            </a:pPr>
+            <a:r>
+              <a:rPr sz="2200">
+                <a:solidFill>
+                  <a:srgbClr val="212121"/>
+                </a:solidFill>
+              </a:rPr>
+              <a:t>Fix (leak_fixed.c): free(p) BEFORE aliasing it.</a:t>
+            </a:r>
+          </a:p>
+          <a:p>
+            <a:pPr lvl="1">
+              <a:spcAft>
+                <a:spcPts val="0"/>
+              </a:spcAft>
+            </a:pPr>
+            <a:r>
+              <a:rPr sz="1800">
+                <a:solidFill>
+                  <a:srgbClr val="212121"/>
+                </a:solidFill>
+                <a:latin typeface="Courier New"/>
+              </a:rPr>
+              <a:t>esbmc leak_fixed.c --memory-leak-check  =&gt;  SUCCESSFUL</a:t>
+            </a:r>
+          </a:p>
+          <a:p>
+            <a:pPr>
+              <a:spcAft>
+                <a:spcPts val="800"/>
+              </a:spcAft>
+            </a:pPr>
+            <a:r>
+              <a:rPr sz="2200">
+                <a:solidFill>
+                  <a:srgbClr val="212121"/>
+                </a:solidFill>
+              </a:rPr>
+              <a:t/>
+            </a:r>
+          </a:p>
+          <a:p>
+            <a:pPr>
+              <a:spcAft>
+                <a:spcPts val="800"/>
+              </a:spcAft>
+            </a:pPr>
+            <a:r>
+              <a:rPr sz="2200">
+                <a:solidFill>
+                  <a:srgbClr val="212121"/>
+                </a:solidFill>
+              </a:rPr>
+              <a:t>Takeaway: a leak is unreachable memory, not just un-freed memory.</a:t>
+            </a:r>
+          </a:p>
+        </p:txBody>
+      </p:sp>
+    </p:spTree>
+  </p:cSld>
+  <p:clrMapOvr>
+    <a:masterClrMapping/>
+  </p:clrMapOvr>
+</p:sld>
+</file>
+
+<file path=ppt/slides/slide7.xml><?xml version="1.0" encoding="utf-8"?>
+<p:sld xmlns:a="http://schemas.openxmlformats.org/drawingml/2006/main" xmlns:p="http://schemas.openxmlformats.org/presentationml/2006/main" xmlns:r="http://schemas.openxmlformats.org/officeDocument/2006/relationships">
+  <p:cSld>
+    <p:spTree>
+      <p:nvGrpSpPr>
+        <p:cNvPr id="1" name=""/>
+        <p:cNvGrpSpPr/>
+        <p:nvPr/>
+      </p:nvGrpSpPr>
+      <p:grpSpPr/>
+      <p:sp>
+        <p:nvSpPr>
+          <p:cNvPr id="2" name="TextBox 1"/>
+          <p:cNvSpPr txBox="1"/>
+          <p:nvPr/>
+        </p:nvSpPr>
+        <p:spPr>
+          <a:xfrm>
+            <a:off x="548640" y="365760"/>
+            <a:ext cx="11064240" cy="1005840"/>
+          </a:xfrm>
+          <a:prstGeom prst="rect">
+            <a:avLst/>
+          </a:prstGeom>
+          <a:noFill/>
+        </p:spPr>
+        <p:txBody>
+          <a:bodyPr wrap="square">
+            <a:spAutoFit/>
+          </a:bodyPr>
+          <a:lstStyle/>
+          <a:p>
+            <a:r>
+              <a:rPr sz="3600" b="1">
+                <a:solidFill>
+                  <a:srgbClr val="5A0A7A"/>
+                </a:solidFill>
+              </a:rPr>
+              <a:t>Lab 2 — vla.c (two bugs)</a:t>
+            </a:r>
+          </a:p>
+        </p:txBody>
+      </p:sp>
+      <p:sp>
+        <p:nvSpPr>
+          <p:cNvPr id="3" name="TextBox 2"/>
+          <p:cNvSpPr txBox="1"/>
+          <p:nvPr/>
+        </p:nvSpPr>
+        <p:spPr>
+          <a:xfrm>
+            <a:off x="731520" y="1463040"/>
+            <a:ext cx="10789920" cy="5120640"/>
+          </a:xfrm>
+          <a:prstGeom prst="rect">
+            <a:avLst/>
+          </a:prstGeom>
+          <a:noFill/>
+        </p:spPr>
+        <p:txBody>
+          <a:bodyPr wrap="square">
+            <a:spAutoFit/>
+          </a:bodyPr>
+          <a:lstStyle/>
+          <a:p>
+            <a:pPr>
+              <a:spcAft>
+                <a:spcPts val="800"/>
+              </a:spcAft>
+            </a:pPr>
+            <a:r>
+              <a:rPr sz="2200">
+                <a:solidFill>
+                  <a:srgbClr val="212121"/>
+                </a:solidFill>
+              </a:rPr>
+              <a:t>Bug 1: the loop runs to size + 1 — one write past a VLA of size n when size == n.</a:t>
+            </a:r>
+          </a:p>
+          <a:p>
+            <a:pPr>
+              <a:spcAft>
+                <a:spcPts val="800"/>
+              </a:spcAft>
+            </a:pPr>
+            <a:r>
+              <a:rPr sz="2200">
+                <a:solidFill>
+                  <a:srgbClr val="212121"/>
+                </a:solidFill>
+              </a:rPr>
+              <a:t>Bug 2: the first call is foo(0, b, 0) — a zero-sized VLA is undefined behaviour before any access.</a:t>
+            </a:r>
+          </a:p>
+          <a:p>
+            <a:pPr>
+              <a:spcAft>
+                <a:spcPts val="800"/>
+              </a:spcAft>
+            </a:pPr>
+            <a:r>
+              <a:rPr sz="2200">
+                <a:solidFill>
+                  <a:srgbClr val="212121"/>
+                </a:solidFill>
+              </a:rPr>
+              <a:t/>
+            </a:r>
+          </a:p>
+          <a:p>
+            <a:pPr>
+              <a:spcAft>
+                <a:spcPts val="800"/>
+              </a:spcAft>
+            </a:pPr>
+            <a:r>
+              <a:rPr sz="2200">
+                <a:solidFill>
+                  <a:srgbClr val="212121"/>
+                </a:solidFill>
+              </a:rPr>
+              <a:t>Fix (vla_fixed.c): guard the sizes, loop strictly below size:</a:t>
+            </a:r>
+          </a:p>
+          <a:p>
+            <a:pPr lvl="1">
+              <a:spcAft>
+                <a:spcPts val="0"/>
+              </a:spcAft>
+            </a:pPr>
+            <a:r>
+              <a:rPr sz="1800">
+                <a:solidFill>
+                  <a:srgbClr val="212121"/>
+                </a:solidFill>
+                <a:latin typeface="Courier New"/>
+              </a:rPr>
+              <a:t>if (n &lt;= 0 || size &gt; n) return 0;</a:t>
+            </a:r>
+          </a:p>
+          <a:p>
+            <a:pPr lvl="1">
+              <a:spcAft>
+                <a:spcPts val="0"/>
+              </a:spcAft>
+            </a:pPr>
+            <a:r>
+              <a:rPr sz="1800">
+                <a:solidFill>
+                  <a:srgbClr val="212121"/>
+                </a:solidFill>
+                <a:latin typeface="Courier New"/>
+              </a:rPr>
+              <a:t>for (i = 0; i &lt; size; i++) a[i] = b[i];</a:t>
+            </a:r>
+          </a:p>
+          <a:p>
+            <a:pPr lvl="1">
+              <a:spcAft>
+                <a:spcPts val="0"/>
+              </a:spcAft>
+            </a:pPr>
+            <a:r>
+              <a:rPr sz="1800">
+                <a:solidFill>
+                  <a:srgbClr val="212121"/>
+                </a:solidFill>
+                <a:latin typeface="Courier New"/>
+              </a:rPr>
+              <a:t>esbmc vla_fixed.c --unwind 6  =&gt;  VERIFICATION SUCCESSFUL</a:t>
+            </a:r>
+          </a:p>
+        </p:txBody>
+      </p:sp>
+    </p:spTree>
+  </p:cSld>
+  <p:clrMapOvr>
+    <a:masterClrMapping/>
+  </p:clrMapOvr>
+</p:sld>
+</file>
+
+<file path=ppt/slides/slide8.xml><?xml version="1.0" encoding="utf-8"?>
+<p:sld xmlns:a="http://schemas.openxmlformats.org/drawingml/2006/main" xmlns:p="http://schemas.openxmlformats.org/presentationml/2006/main" xmlns:r="http://schemas.openxmlformats.org/officeDocument/2006/relationships">
+  <p:cSld>
+    <p:spTree>
+      <p:nvGrpSpPr>
+        <p:cNvPr id="1" name=""/>
+        <p:cNvGrpSpPr/>
+        <p:nvPr/>
+      </p:nvGrpSpPr>
+      <p:grpSpPr/>
+      <p:sp>
+        <p:nvSpPr>
+          <p:cNvPr id="2" name="TextBox 1"/>
+          <p:cNvSpPr txBox="1"/>
+          <p:nvPr/>
+        </p:nvSpPr>
+        <p:spPr>
+          <a:xfrm>
+            <a:off x="548640" y="365760"/>
+            <a:ext cx="11064240" cy="1005840"/>
+          </a:xfrm>
+          <a:prstGeom prst="rect">
+            <a:avLst/>
+          </a:prstGeom>
+          <a:noFill/>
+        </p:spPr>
+        <p:txBody>
+          <a:bodyPr wrap="square">
+            <a:spAutoFit/>
+          </a:bodyPr>
+          <a:lstStyle/>
+          <a:p>
+            <a:r>
+              <a:rPr sz="3600" b="1">
+                <a:solidFill>
+                  <a:srgbClr val="5A0A7A"/>
+                </a:solidFill>
+              </a:rPr>
+              <a:t>Lab 2 — getpassword.c (stretch)</a:t>
+            </a:r>
+          </a:p>
+        </p:txBody>
+      </p:sp>
+      <p:sp>
+        <p:nvSpPr>
+          <p:cNvPr id="3" name="TextBox 2"/>
+          <p:cNvSpPr txBox="1"/>
+          <p:nvPr/>
+        </p:nvSpPr>
+        <p:spPr>
+          <a:xfrm>
+            <a:off x="731520" y="1463040"/>
+            <a:ext cx="10789920" cy="5120640"/>
+          </a:xfrm>
+          <a:prstGeom prst="rect">
+            <a:avLst/>
+          </a:prstGeom>
+          <a:noFill/>
+        </p:spPr>
+        <p:txBody>
+          <a:bodyPr wrap="square">
+            <a:spAutoFit/>
+          </a:bodyPr>
+          <a:lstStyle/>
+          <a:p>
+            <a:pPr>
+              <a:spcAft>
+                <a:spcPts val="800"/>
+              </a:spcAft>
+            </a:pPr>
+            <a:r>
+              <a:rPr sz="2200">
+                <a:solidFill>
+                  <a:srgbClr val="212121"/>
+                </a:solidFill>
+              </a:rPr>
+              <a:t>Fix (getpassword_fixed.c): bounded read, strip the newline:</a:t>
+            </a:r>
+          </a:p>
+          <a:p>
+            <a:pPr lvl="1">
+              <a:spcAft>
+                <a:spcPts val="0"/>
+              </a:spcAft>
+            </a:pPr>
+            <a:r>
+              <a:rPr sz="1800">
+                <a:solidFill>
+                  <a:srgbClr val="212121"/>
+                </a:solidFill>
+                <a:latin typeface="Courier New"/>
+              </a:rPr>
+              <a:t>if (!fgets(buf, sizeof(buf), stdin)) return 1;</a:t>
+            </a:r>
+          </a:p>
+          <a:p>
+            <a:pPr lvl="1">
+              <a:spcAft>
+                <a:spcPts val="0"/>
+              </a:spcAft>
+            </a:pPr>
+            <a:r>
+              <a:rPr sz="1800">
+                <a:solidFill>
+                  <a:srgbClr val="212121"/>
+                </a:solidFill>
+                <a:latin typeface="Courier New"/>
+              </a:rPr>
+              <a:t>buf[strcspn(buf, "\n")] = '\0';</a:t>
+            </a:r>
+          </a:p>
+          <a:p>
+            <a:pPr>
+              <a:spcAft>
+                <a:spcPts val="800"/>
+              </a:spcAft>
+            </a:pPr>
+            <a:r>
+              <a:rPr sz="2200">
+                <a:solidFill>
+                  <a:srgbClr val="212121"/>
+                </a:solidFill>
+              </a:rPr>
+              <a:t/>
+            </a:r>
+          </a:p>
+          <a:p>
+            <a:pPr>
+              <a:spcAft>
+                <a:spcPts val="800"/>
+              </a:spcAft>
+            </a:pPr>
+            <a:r>
+              <a:rPr sz="2200">
+                <a:solidFill>
+                  <a:srgbClr val="212121"/>
+                </a:solidFill>
+              </a:rPr>
+              <a:t>Gotcha: the fixed file (char buf[8]) needs --unwind 10, not 8 — the fgets model iterates further.</a:t>
+            </a:r>
+          </a:p>
+          <a:p>
+            <a:pPr lvl="1">
+              <a:spcAft>
+                <a:spcPts val="800"/>
+              </a:spcAft>
+            </a:pPr>
+            <a:r>
+              <a:rPr sz="2000">
+                <a:solidFill>
+                  <a:srgbClr val="212121"/>
+                </a:solidFill>
+              </a:rPr>
+              <a:t>A minimal fix keeping buf[4] verifies at --unwind 8.</a:t>
+            </a:r>
+          </a:p>
+          <a:p>
+            <a:pPr>
+              <a:spcAft>
+                <a:spcPts val="800"/>
+              </a:spcAft>
+            </a:pPr>
+            <a:r>
+              <a:rPr sz="2200">
+                <a:solidFill>
+                  <a:srgbClr val="212121"/>
+                </a:solidFill>
+              </a:rPr>
+              <a:t/>
+            </a:r>
+          </a:p>
+          <a:p>
+            <a:pPr>
+              <a:spcAft>
+                <a:spcPts val="800"/>
+              </a:spcAft>
+            </a:pPr>
+            <a:r>
+              <a:rPr sz="2200">
+                <a:solidFill>
+                  <a:srgbClr val="212121"/>
+                </a:solidFill>
+              </a:rPr>
+              <a:t>Discussion bridge: why does the right bound depend on the code? → Lab 3, Part 2.</a:t>
+            </a:r>
+          </a:p>
+        </p:txBody>
+      </p:sp>
+    </p:spTree>
+  </p:cSld>
+  <p:clrMapOvr>
+    <a:masterClrMapping/>
+  </p:clrMapOvr>
+</p:sld>
+</file>
+
+<file path=ppt/slides/slide9.xml><?xml version="1.0" encoding="utf-8"?>
+<p:sld xmlns:a="http://schemas.openxmlformats.org/drawingml/2006/main" xmlns:p="http://schemas.openxmlformats.org/presentationml/2006/main" xmlns:r="http://schemas.openxmlformats.org/officeDocument/2006/relationships">
+  <p:cSld>
+    <p:spTree>
+      <p:nvGrpSpPr>
+        <p:cNvPr id="1" name=""/>
+        <p:cNvGrpSpPr/>
+        <p:nvPr/>
+      </p:nvGrpSpPr>
+      <p:grpSpPr/>
+      <p:sp>
+        <p:nvSpPr>
+          <p:cNvPr id="2" name="TextBox 1"/>
+          <p:cNvSpPr txBox="1"/>
+          <p:nvPr/>
+        </p:nvSpPr>
+        <p:spPr>
+          <a:xfrm>
+            <a:off x="548640" y="365760"/>
+            <a:ext cx="11064240" cy="1005840"/>
+          </a:xfrm>
+          <a:prstGeom prst="rect">
+            <a:avLst/>
+          </a:prstGeom>
+          <a:noFill/>
+        </p:spPr>
+        <p:txBody>
+          <a:bodyPr wrap="square">
+            <a:spAutoFit/>
+          </a:bodyPr>
+          <a:lstStyle/>
+          <a:p>
+            <a:r>
+              <a:rPr sz="3600" b="1">
+                <a:solidFill>
+                  <a:srgbClr val="5A0A7A"/>
+                </a:solidFill>
+              </a:rPr>
+              <a:t>Lab 3 — triangle.c</a:t>
+            </a:r>
+          </a:p>
+        </p:txBody>
+      </p:sp>
+      <p:sp>
+        <p:nvSpPr>
+          <p:cNvPr id="3" name="TextBox 2"/>
+          <p:cNvSpPr txBox="1"/>
+          <p:nvPr/>
+        </p:nvSpPr>
+        <p:spPr>
+          <a:xfrm>
+            <a:off x="731520" y="1463040"/>
+            <a:ext cx="10789920" cy="5120640"/>
+          </a:xfrm>
+          <a:prstGeom prst="rect">
+            <a:avLst/>
+          </a:prstGeom>
+          <a:noFill/>
+        </p:spPr>
+        <p:txBody>
+          <a:bodyPr wrap="square">
+            <a:spAutoFit/>
+          </a:bodyPr>
+          <a:lstStyle/>
+          <a:p>
+            <a:pPr>
+              <a:spcAft>
+                <a:spcPts val="800"/>
+              </a:spcAft>
+            </a:pPr>
+            <a:r>
+              <a:rPr sz="2200">
+                <a:solidFill>
+                  <a:srgbClr val="212121"/>
+                </a:solidFill>
+              </a:rPr>
+              <a:t>Seeded bug: classify() forgot the third inequality b + c &lt;= a.</a:t>
+            </a:r>
+          </a:p>
+          <a:p>
+            <a:pPr>
+              <a:spcAft>
+                <a:spcPts val="800"/>
+              </a:spcAft>
+            </a:pPr>
+            <a:r>
+              <a:rPr sz="2200">
+                <a:solidFill>
+                  <a:srgbClr val="212121"/>
+                </a:solidFill>
+              </a:rPr>
+              <a:t/>
+            </a:r>
+          </a:p>
+          <a:p>
+            <a:pPr>
+              <a:spcAft>
+                <a:spcPts val="800"/>
+              </a:spcAft>
+            </a:pPr>
+            <a:r>
+              <a:rPr sz="2200">
+                <a:solidFill>
+                  <a:srgbClr val="212121"/>
+                </a:solidFill>
+              </a:rPr>
+              <a:t>The two TODO properties (triangle_solution.c):</a:t>
+            </a:r>
+          </a:p>
+          <a:p>
+            <a:pPr lvl="1">
+              <a:spcAft>
+                <a:spcPts val="0"/>
+              </a:spcAft>
+            </a:pPr>
+            <a:r>
+              <a:rPr sz="1800">
+                <a:solidFill>
+                  <a:srgbClr val="212121"/>
+                </a:solidFill>
+                <a:latin typeface="Courier New"/>
+              </a:rPr>
+              <a:t>assert(!(a+b&lt;=c || a+c&lt;=b || b+c&lt;=a) || r == 4);  /* P3 */</a:t>
+            </a:r>
+          </a:p>
+          <a:p>
+            <a:pPr lvl="1">
+              <a:spcAft>
+                <a:spcPts val="0"/>
+              </a:spcAft>
+            </a:pPr>
+            <a:r>
+              <a:rPr sz="1800">
+                <a:solidFill>
+                  <a:srgbClr val="212121"/>
+                </a:solidFill>
+                <a:latin typeface="Courier New"/>
+              </a:rPr>
+              <a:t>assert(classify(a, b, c) == classify(c, b, a));   /* P4 */</a:t>
+            </a:r>
+          </a:p>
+          <a:p>
+            <a:pPr>
+              <a:spcAft>
+                <a:spcPts val="800"/>
+              </a:spcAft>
+            </a:pPr>
+            <a:r>
+              <a:rPr sz="2200">
+                <a:solidFill>
+                  <a:srgbClr val="212121"/>
+                </a:solidFill>
+              </a:rPr>
+              <a:t/>
+            </a:r>
+          </a:p>
+          <a:p>
+            <a:pPr>
+              <a:spcAft>
+                <a:spcPts val="800"/>
+              </a:spcAft>
+            </a:pPr>
+            <a:r>
+              <a:rPr sz="2200">
+                <a:solidFill>
+                  <a:srgbClr val="212121"/>
+                </a:solidFill>
+              </a:rPr>
+              <a:t>Observed counterexamples — both correct outcomes of the same bug:</a:t>
+            </a:r>
+          </a:p>
+          <a:p>
+            <a:pPr lvl="1">
+              <a:spcAft>
+                <a:spcPts val="800"/>
+              </a:spcAft>
+            </a:pPr>
+            <a:r>
+              <a:rPr sz="2000">
+                <a:solidFill>
+                  <a:srgbClr val="212121"/>
+                </a:solidFill>
+              </a:rPr>
+              <a:t>a=999, b=1, c=1 fires P3 directly;  a=512, b=256, c=768 fires P4.</a:t>
+            </a:r>
+          </a:p>
+          <a:p>
+            <a:pPr>
+              <a:spcAft>
+                <a:spcPts val="800"/>
+              </a:spcAft>
+            </a:pPr>
+            <a:r>
+              <a:rPr sz="2200">
+                <a:solidFill>
+                  <a:srgbClr val="212121"/>
+                </a:solidFill>
+              </a:rPr>
+              <a:t>Fixed + specified: VERIFICATION SUCCESSFUL in ~0.5 s.</a:t>
             </a:r>
           </a:p>
         </p:txBody>

</xml_diff>